<commit_message>
Update and Add new hymns
</commit_message>
<xml_diff>
--- a/中越詩歌/我要唱快樂頌_Mừng ngày.pptx
+++ b/中越詩歌/我要唱快樂頌_Mừng ngày.pptx
@@ -7,13 +7,17 @@
   <p:sldIdLst>
     <p:sldId id="257" r:id="rId2"/>
     <p:sldId id="258" r:id="rId3"/>
-    <p:sldId id="259" r:id="rId4"/>
-    <p:sldId id="260" r:id="rId5"/>
-    <p:sldId id="261" r:id="rId6"/>
-    <p:sldId id="262" r:id="rId7"/>
-    <p:sldId id="263" r:id="rId8"/>
-    <p:sldId id="264" r:id="rId9"/>
-    <p:sldId id="265" r:id="rId10"/>
+    <p:sldId id="266" r:id="rId4"/>
+    <p:sldId id="259" r:id="rId5"/>
+    <p:sldId id="267" r:id="rId6"/>
+    <p:sldId id="260" r:id="rId7"/>
+    <p:sldId id="268" r:id="rId8"/>
+    <p:sldId id="261" r:id="rId9"/>
+    <p:sldId id="269" r:id="rId10"/>
+    <p:sldId id="262" r:id="rId11"/>
+    <p:sldId id="263" r:id="rId12"/>
+    <p:sldId id="264" r:id="rId13"/>
+    <p:sldId id="265" r:id="rId14"/>
   </p:sldIdLst>
   <p:sldSz cx="12192000" cy="6858000"/>
   <p:notesSz cx="6858000" cy="9144000"/>
@@ -301,7 +305,7 @@
           <a:p>
             <a:fld id="{7F34E370-1F60-4349-8241-6663164F08B2}" type="datetimeFigureOut">
               <a:rPr lang="vi-VN" smtClean="0"/>
-              <a:t>25/12/2023</a:t>
+              <a:t>21/12/2025</a:t>
             </a:fld>
             <a:endParaRPr lang="vi-VN"/>
           </a:p>
@@ -471,7 +475,7 @@
           <a:p>
             <a:fld id="{7F34E370-1F60-4349-8241-6663164F08B2}" type="datetimeFigureOut">
               <a:rPr lang="vi-VN" smtClean="0"/>
-              <a:t>25/12/2023</a:t>
+              <a:t>21/12/2025</a:t>
             </a:fld>
             <a:endParaRPr lang="vi-VN"/>
           </a:p>
@@ -651,7 +655,7 @@
           <a:p>
             <a:fld id="{7F34E370-1F60-4349-8241-6663164F08B2}" type="datetimeFigureOut">
               <a:rPr lang="vi-VN" smtClean="0"/>
-              <a:t>25/12/2023</a:t>
+              <a:t>21/12/2025</a:t>
             </a:fld>
             <a:endParaRPr lang="vi-VN"/>
           </a:p>
@@ -821,7 +825,7 @@
           <a:p>
             <a:fld id="{7F34E370-1F60-4349-8241-6663164F08B2}" type="datetimeFigureOut">
               <a:rPr lang="vi-VN" smtClean="0"/>
-              <a:t>25/12/2023</a:t>
+              <a:t>21/12/2025</a:t>
             </a:fld>
             <a:endParaRPr lang="vi-VN"/>
           </a:p>
@@ -1067,7 +1071,7 @@
           <a:p>
             <a:fld id="{7F34E370-1F60-4349-8241-6663164F08B2}" type="datetimeFigureOut">
               <a:rPr lang="vi-VN" smtClean="0"/>
-              <a:t>25/12/2023</a:t>
+              <a:t>21/12/2025</a:t>
             </a:fld>
             <a:endParaRPr lang="vi-VN"/>
           </a:p>
@@ -1355,7 +1359,7 @@
           <a:p>
             <a:fld id="{7F34E370-1F60-4349-8241-6663164F08B2}" type="datetimeFigureOut">
               <a:rPr lang="vi-VN" smtClean="0"/>
-              <a:t>25/12/2023</a:t>
+              <a:t>21/12/2025</a:t>
             </a:fld>
             <a:endParaRPr lang="vi-VN"/>
           </a:p>
@@ -1777,7 +1781,7 @@
           <a:p>
             <a:fld id="{7F34E370-1F60-4349-8241-6663164F08B2}" type="datetimeFigureOut">
               <a:rPr lang="vi-VN" smtClean="0"/>
-              <a:t>25/12/2023</a:t>
+              <a:t>21/12/2025</a:t>
             </a:fld>
             <a:endParaRPr lang="vi-VN"/>
           </a:p>
@@ -1895,7 +1899,7 @@
           <a:p>
             <a:fld id="{7F34E370-1F60-4349-8241-6663164F08B2}" type="datetimeFigureOut">
               <a:rPr lang="vi-VN" smtClean="0"/>
-              <a:t>25/12/2023</a:t>
+              <a:t>21/12/2025</a:t>
             </a:fld>
             <a:endParaRPr lang="vi-VN"/>
           </a:p>
@@ -1990,7 +1994,7 @@
           <a:p>
             <a:fld id="{7F34E370-1F60-4349-8241-6663164F08B2}" type="datetimeFigureOut">
               <a:rPr lang="vi-VN" smtClean="0"/>
-              <a:t>25/12/2023</a:t>
+              <a:t>21/12/2025</a:t>
             </a:fld>
             <a:endParaRPr lang="vi-VN"/>
           </a:p>
@@ -2267,7 +2271,7 @@
           <a:p>
             <a:fld id="{7F34E370-1F60-4349-8241-6663164F08B2}" type="datetimeFigureOut">
               <a:rPr lang="vi-VN" smtClean="0"/>
-              <a:t>25/12/2023</a:t>
+              <a:t>21/12/2025</a:t>
             </a:fld>
             <a:endParaRPr lang="vi-VN"/>
           </a:p>
@@ -2524,7 +2528,7 @@
           <a:p>
             <a:fld id="{7F34E370-1F60-4349-8241-6663164F08B2}" type="datetimeFigureOut">
               <a:rPr lang="vi-VN" smtClean="0"/>
-              <a:t>25/12/2023</a:t>
+              <a:t>21/12/2025</a:t>
             </a:fld>
             <a:endParaRPr lang="vi-VN"/>
           </a:p>
@@ -2740,7 +2744,7 @@
           <a:p>
             <a:fld id="{7F34E370-1F60-4349-8241-6663164F08B2}" type="datetimeFigureOut">
               <a:rPr lang="vi-VN" smtClean="0"/>
-              <a:t>25/12/2023</a:t>
+              <a:t>21/12/2025</a:t>
             </a:fld>
             <a:endParaRPr lang="vi-VN"/>
           </a:p>
@@ -3260,6 +3264,1290 @@
 </p:sld>
 </file>
 
+<file path=ppt/slides/slide10.xml><?xml version="1.0" encoding="utf-8"?>
+<p:sld xmlns:a="http://schemas.openxmlformats.org/drawingml/2006/main" xmlns:r="http://schemas.openxmlformats.org/officeDocument/2006/relationships" xmlns:p="http://schemas.openxmlformats.org/presentationml/2006/main">
+  <p:cSld>
+    <p:spTree>
+      <p:nvGrpSpPr>
+        <p:cNvPr id="1" name=""/>
+        <p:cNvGrpSpPr/>
+        <p:nvPr/>
+      </p:nvGrpSpPr>
+      <p:grpSpPr>
+        <a:xfrm>
+          <a:off x="0" y="0"/>
+          <a:ext cx="0" cy="0"/>
+          <a:chOff x="0" y="0"/>
+          <a:chExt cx="0" cy="0"/>
+        </a:xfrm>
+      </p:grpSpPr>
+      <p:sp>
+        <p:nvSpPr>
+          <p:cNvPr id="6" name="內容版面配置區 4"/>
+          <p:cNvSpPr>
+            <a:spLocks noGrp="1"/>
+          </p:cNvSpPr>
+          <p:nvPr>
+            <p:ph idx="1"/>
+          </p:nvPr>
+        </p:nvSpPr>
+        <p:spPr>
+          <a:xfrm>
+            <a:off x="0" y="2167981"/>
+            <a:ext cx="12192000" cy="1318225"/>
+          </a:xfrm>
+        </p:spPr>
+        <p:txBody>
+          <a:bodyPr anchor="ctr">
+            <a:normAutofit/>
+          </a:bodyPr>
+          <a:lstStyle/>
+          <a:p>
+            <a:pPr algn="ctr">
+              <a:buNone/>
+            </a:pPr>
+            <a:r>
+              <a:rPr lang="zh-TW" altLang="en-US" sz="6400" b="1" dirty="0">
+                <a:solidFill>
+                  <a:srgbClr val="000066"/>
+                </a:solidFill>
+                <a:latin typeface="微軟正黑體" pitchFamily="34" charset="-120"/>
+                <a:ea typeface="微軟正黑體" pitchFamily="34" charset="-120"/>
+              </a:rPr>
+              <a:t>閃星星  閃星星  救主已降生</a:t>
+            </a:r>
+            <a:endParaRPr lang="en-US" altLang="zh-CN" sz="6400" b="1" dirty="0">
+              <a:solidFill>
+                <a:srgbClr val="000066"/>
+              </a:solidFill>
+              <a:latin typeface="微軟正黑體" pitchFamily="34" charset="-120"/>
+              <a:ea typeface="微軟正黑體" pitchFamily="34" charset="-120"/>
+            </a:endParaRPr>
+          </a:p>
+        </p:txBody>
+      </p:sp>
+      <p:sp>
+        <p:nvSpPr>
+          <p:cNvPr id="7" name="內容版面配置區 4"/>
+          <p:cNvSpPr txBox="1">
+            <a:spLocks/>
+          </p:cNvSpPr>
+          <p:nvPr/>
+        </p:nvSpPr>
+        <p:spPr>
+          <a:xfrm>
+            <a:off x="0" y="3117530"/>
+            <a:ext cx="12192000" cy="1318225"/>
+          </a:xfrm>
+          <a:prstGeom prst="rect">
+            <a:avLst/>
+          </a:prstGeom>
+        </p:spPr>
+        <p:txBody>
+          <a:bodyPr vert="horz" lIns="91440" tIns="45720" rIns="91440" bIns="45720" rtlCol="0" anchor="ctr">
+            <a:normAutofit/>
+          </a:bodyPr>
+          <a:lstStyle>
+            <a:lvl1pPr marL="457189" indent="-457189" algn="l" defTabSz="1219170" rtl="0" eaLnBrk="1" latinLnBrk="0" hangingPunct="1">
+              <a:spcBef>
+                <a:spcPct val="20000"/>
+              </a:spcBef>
+              <a:buFont typeface="Arial" pitchFamily="34" charset="0"/>
+              <a:buChar char="•"/>
+              <a:defRPr sz="4267" kern="1200">
+                <a:solidFill>
+                  <a:schemeClr val="tx1"/>
+                </a:solidFill>
+                <a:latin typeface="+mn-lt"/>
+                <a:ea typeface="+mn-ea"/>
+                <a:cs typeface="+mn-cs"/>
+              </a:defRPr>
+            </a:lvl1pPr>
+            <a:lvl2pPr marL="990575" indent="-380990" algn="l" defTabSz="1219170" rtl="0" eaLnBrk="1" latinLnBrk="0" hangingPunct="1">
+              <a:spcBef>
+                <a:spcPct val="20000"/>
+              </a:spcBef>
+              <a:buFont typeface="Arial" pitchFamily="34" charset="0"/>
+              <a:buChar char="–"/>
+              <a:defRPr sz="3733" kern="1200">
+                <a:solidFill>
+                  <a:schemeClr val="tx1"/>
+                </a:solidFill>
+                <a:latin typeface="+mn-lt"/>
+                <a:ea typeface="+mn-ea"/>
+                <a:cs typeface="+mn-cs"/>
+              </a:defRPr>
+            </a:lvl2pPr>
+            <a:lvl3pPr marL="1523962" indent="-304792" algn="l" defTabSz="1219170" rtl="0" eaLnBrk="1" latinLnBrk="0" hangingPunct="1">
+              <a:spcBef>
+                <a:spcPct val="20000"/>
+              </a:spcBef>
+              <a:buFont typeface="Arial" pitchFamily="34" charset="0"/>
+              <a:buChar char="•"/>
+              <a:defRPr sz="3200" kern="1200">
+                <a:solidFill>
+                  <a:schemeClr val="tx1"/>
+                </a:solidFill>
+                <a:latin typeface="+mn-lt"/>
+                <a:ea typeface="+mn-ea"/>
+                <a:cs typeface="+mn-cs"/>
+              </a:defRPr>
+            </a:lvl3pPr>
+            <a:lvl4pPr marL="2133547" indent="-304792" algn="l" defTabSz="1219170" rtl="0" eaLnBrk="1" latinLnBrk="0" hangingPunct="1">
+              <a:spcBef>
+                <a:spcPct val="20000"/>
+              </a:spcBef>
+              <a:buFont typeface="Arial" pitchFamily="34" charset="0"/>
+              <a:buChar char="–"/>
+              <a:defRPr sz="2667" kern="1200">
+                <a:solidFill>
+                  <a:schemeClr val="tx1"/>
+                </a:solidFill>
+                <a:latin typeface="+mn-lt"/>
+                <a:ea typeface="+mn-ea"/>
+                <a:cs typeface="+mn-cs"/>
+              </a:defRPr>
+            </a:lvl4pPr>
+            <a:lvl5pPr marL="2743131" indent="-304792" algn="l" defTabSz="1219170" rtl="0" eaLnBrk="1" latinLnBrk="0" hangingPunct="1">
+              <a:spcBef>
+                <a:spcPct val="20000"/>
+              </a:spcBef>
+              <a:buFont typeface="Arial" pitchFamily="34" charset="0"/>
+              <a:buChar char="»"/>
+              <a:defRPr sz="2667" kern="1200">
+                <a:solidFill>
+                  <a:schemeClr val="tx1"/>
+                </a:solidFill>
+                <a:latin typeface="+mn-lt"/>
+                <a:ea typeface="+mn-ea"/>
+                <a:cs typeface="+mn-cs"/>
+              </a:defRPr>
+            </a:lvl5pPr>
+            <a:lvl6pPr marL="3352716" indent="-304792" algn="l" defTabSz="1219170" rtl="0" eaLnBrk="1" latinLnBrk="0" hangingPunct="1">
+              <a:spcBef>
+                <a:spcPct val="20000"/>
+              </a:spcBef>
+              <a:buFont typeface="Arial" pitchFamily="34" charset="0"/>
+              <a:buChar char="•"/>
+              <a:defRPr sz="2667" kern="1200">
+                <a:solidFill>
+                  <a:schemeClr val="tx1"/>
+                </a:solidFill>
+                <a:latin typeface="+mn-lt"/>
+                <a:ea typeface="+mn-ea"/>
+                <a:cs typeface="+mn-cs"/>
+              </a:defRPr>
+            </a:lvl6pPr>
+            <a:lvl7pPr marL="3962301" indent="-304792" algn="l" defTabSz="1219170" rtl="0" eaLnBrk="1" latinLnBrk="0" hangingPunct="1">
+              <a:spcBef>
+                <a:spcPct val="20000"/>
+              </a:spcBef>
+              <a:buFont typeface="Arial" pitchFamily="34" charset="0"/>
+              <a:buChar char="•"/>
+              <a:defRPr sz="2667" kern="1200">
+                <a:solidFill>
+                  <a:schemeClr val="tx1"/>
+                </a:solidFill>
+                <a:latin typeface="+mn-lt"/>
+                <a:ea typeface="+mn-ea"/>
+                <a:cs typeface="+mn-cs"/>
+              </a:defRPr>
+            </a:lvl7pPr>
+            <a:lvl8pPr marL="4571886" indent="-304792" algn="l" defTabSz="1219170" rtl="0" eaLnBrk="1" latinLnBrk="0" hangingPunct="1">
+              <a:spcBef>
+                <a:spcPct val="20000"/>
+              </a:spcBef>
+              <a:buFont typeface="Arial" pitchFamily="34" charset="0"/>
+              <a:buChar char="•"/>
+              <a:defRPr sz="2667" kern="1200">
+                <a:solidFill>
+                  <a:schemeClr val="tx1"/>
+                </a:solidFill>
+                <a:latin typeface="+mn-lt"/>
+                <a:ea typeface="+mn-ea"/>
+                <a:cs typeface="+mn-cs"/>
+              </a:defRPr>
+            </a:lvl8pPr>
+            <a:lvl9pPr marL="5181470" indent="-304792" algn="l" defTabSz="1219170" rtl="0" eaLnBrk="1" latinLnBrk="0" hangingPunct="1">
+              <a:spcBef>
+                <a:spcPct val="20000"/>
+              </a:spcBef>
+              <a:buFont typeface="Arial" pitchFamily="34" charset="0"/>
+              <a:buChar char="•"/>
+              <a:defRPr sz="2667" kern="1200">
+                <a:solidFill>
+                  <a:schemeClr val="tx1"/>
+                </a:solidFill>
+                <a:latin typeface="+mn-lt"/>
+                <a:ea typeface="+mn-ea"/>
+                <a:cs typeface="+mn-cs"/>
+              </a:defRPr>
+            </a:lvl9pPr>
+          </a:lstStyle>
+          <a:p>
+            <a:pPr marL="0" indent="0" algn="ctr">
+              <a:buNone/>
+            </a:pPr>
+            <a:r>
+              <a:rPr lang="vi-VN" sz="4400" b="1" dirty="0">
+                <a:solidFill>
+                  <a:srgbClr val="660033"/>
+                </a:solidFill>
+                <a:latin typeface="Calibri" panose="020F0502020204030204" pitchFamily="34" charset="0"/>
+                <a:ea typeface="微軟正黑體" pitchFamily="34" charset="-120"/>
+                <a:cs typeface="Calibri" panose="020F0502020204030204" pitchFamily="34" charset="0"/>
+              </a:rPr>
+              <a:t>Đêm Noel, đêm Noel, ta hãy cùng vui lên</a:t>
+            </a:r>
+            <a:endParaRPr lang="en-US" sz="4400" b="1" dirty="0">
+              <a:solidFill>
+                <a:srgbClr val="660033"/>
+              </a:solidFill>
+              <a:latin typeface="Calibri" panose="020F0502020204030204" pitchFamily="34" charset="0"/>
+              <a:ea typeface="微軟正黑體" pitchFamily="34" charset="-120"/>
+              <a:cs typeface="Calibri" panose="020F0502020204030204" pitchFamily="34" charset="0"/>
+            </a:endParaRPr>
+          </a:p>
+        </p:txBody>
+      </p:sp>
+      <p:sp>
+        <p:nvSpPr>
+          <p:cNvPr id="8" name="TextBox 7"/>
+          <p:cNvSpPr txBox="1"/>
+          <p:nvPr/>
+        </p:nvSpPr>
+        <p:spPr>
+          <a:xfrm>
+            <a:off x="0" y="5253203"/>
+            <a:ext cx="12192000" cy="646331"/>
+          </a:xfrm>
+          <a:prstGeom prst="rect">
+            <a:avLst/>
+          </a:prstGeom>
+          <a:noFill/>
+        </p:spPr>
+        <p:txBody>
+          <a:bodyPr wrap="square" rtlCol="0">
+            <a:spAutoFit/>
+          </a:bodyPr>
+          <a:lstStyle/>
+          <a:p>
+            <a:pPr algn="ctr"/>
+            <a:r>
+              <a:rPr lang="en-US" sz="3600" b="1" dirty="0">
+                <a:solidFill>
+                  <a:srgbClr val="000066"/>
+                </a:solidFill>
+                <a:latin typeface="Microsoft JhengHei" panose="020B0604030504040204" pitchFamily="34" charset="-120"/>
+                <a:ea typeface="Microsoft JhengHei" panose="020B0604030504040204" pitchFamily="34" charset="-120"/>
+              </a:rPr>
+              <a:t>( </a:t>
+            </a:r>
+            <a:r>
+              <a:rPr lang="zh-CN" altLang="en-US" sz="3600" b="1" dirty="0">
+                <a:solidFill>
+                  <a:srgbClr val="000066"/>
+                </a:solidFill>
+                <a:latin typeface="Microsoft JhengHei" panose="020B0604030504040204" pitchFamily="34" charset="-120"/>
+                <a:ea typeface="Microsoft JhengHei" panose="020B0604030504040204" pitchFamily="34" charset="-120"/>
+              </a:rPr>
+              <a:t>副歌</a:t>
+            </a:r>
+            <a:r>
+              <a:rPr lang="en-US" sz="3600" b="1" dirty="0">
+                <a:solidFill>
+                  <a:srgbClr val="000066"/>
+                </a:solidFill>
+                <a:latin typeface="Microsoft JhengHei" panose="020B0604030504040204" pitchFamily="34" charset="-120"/>
+                <a:ea typeface="Microsoft JhengHei" panose="020B0604030504040204" pitchFamily="34" charset="-120"/>
+              </a:rPr>
+              <a:t> )</a:t>
+            </a:r>
+            <a:endParaRPr lang="vi-VN" sz="3600" b="1" dirty="0">
+              <a:solidFill>
+                <a:srgbClr val="000066"/>
+              </a:solidFill>
+              <a:ea typeface="Microsoft JhengHei" panose="020B0604030504040204" pitchFamily="34" charset="-120"/>
+            </a:endParaRPr>
+          </a:p>
+        </p:txBody>
+      </p:sp>
+    </p:spTree>
+    <p:extLst>
+      <p:ext uri="{BB962C8B-B14F-4D97-AF65-F5344CB8AC3E}">
+        <p14:creationId xmlns:p14="http://schemas.microsoft.com/office/powerpoint/2010/main" val="1232539337"/>
+      </p:ext>
+    </p:extLst>
+  </p:cSld>
+  <p:clrMapOvr>
+    <a:masterClrMapping/>
+  </p:clrMapOvr>
+</p:sld>
+</file>
+
+<file path=ppt/slides/slide11.xml><?xml version="1.0" encoding="utf-8"?>
+<p:sld xmlns:a="http://schemas.openxmlformats.org/drawingml/2006/main" xmlns:r="http://schemas.openxmlformats.org/officeDocument/2006/relationships" xmlns:p="http://schemas.openxmlformats.org/presentationml/2006/main">
+  <p:cSld>
+    <p:spTree>
+      <p:nvGrpSpPr>
+        <p:cNvPr id="1" name=""/>
+        <p:cNvGrpSpPr/>
+        <p:nvPr/>
+      </p:nvGrpSpPr>
+      <p:grpSpPr>
+        <a:xfrm>
+          <a:off x="0" y="0"/>
+          <a:ext cx="0" cy="0"/>
+          <a:chOff x="0" y="0"/>
+          <a:chExt cx="0" cy="0"/>
+        </a:xfrm>
+      </p:grpSpPr>
+      <p:sp>
+        <p:nvSpPr>
+          <p:cNvPr id="6" name="內容版面配置區 4"/>
+          <p:cNvSpPr>
+            <a:spLocks noGrp="1"/>
+          </p:cNvSpPr>
+          <p:nvPr>
+            <p:ph idx="1"/>
+          </p:nvPr>
+        </p:nvSpPr>
+        <p:spPr>
+          <a:xfrm>
+            <a:off x="0" y="2167981"/>
+            <a:ext cx="12192000" cy="1318225"/>
+          </a:xfrm>
+        </p:spPr>
+        <p:txBody>
+          <a:bodyPr anchor="ctr">
+            <a:normAutofit/>
+          </a:bodyPr>
+          <a:lstStyle/>
+          <a:p>
+            <a:pPr algn="ctr">
+              <a:buNone/>
+            </a:pPr>
+            <a:r>
+              <a:rPr lang="zh-TW" altLang="en-US" sz="6400" b="1" dirty="0">
+                <a:solidFill>
+                  <a:srgbClr val="000066"/>
+                </a:solidFill>
+                <a:latin typeface="微軟正黑體" pitchFamily="34" charset="-120"/>
+                <a:ea typeface="微軟正黑體" pitchFamily="34" charset="-120"/>
+              </a:rPr>
+              <a:t>聖誕節  多開心  萬民同頌神恩</a:t>
+            </a:r>
+            <a:endParaRPr lang="en-US" altLang="zh-CN" sz="6400" b="1" dirty="0">
+              <a:solidFill>
+                <a:srgbClr val="000066"/>
+              </a:solidFill>
+              <a:latin typeface="微軟正黑體" pitchFamily="34" charset="-120"/>
+              <a:ea typeface="微軟正黑體" pitchFamily="34" charset="-120"/>
+            </a:endParaRPr>
+          </a:p>
+        </p:txBody>
+      </p:sp>
+      <p:sp>
+        <p:nvSpPr>
+          <p:cNvPr id="7" name="內容版面配置區 4"/>
+          <p:cNvSpPr txBox="1">
+            <a:spLocks/>
+          </p:cNvSpPr>
+          <p:nvPr/>
+        </p:nvSpPr>
+        <p:spPr>
+          <a:xfrm>
+            <a:off x="0" y="3117530"/>
+            <a:ext cx="12192000" cy="1318225"/>
+          </a:xfrm>
+          <a:prstGeom prst="rect">
+            <a:avLst/>
+          </a:prstGeom>
+        </p:spPr>
+        <p:txBody>
+          <a:bodyPr vert="horz" lIns="91440" tIns="45720" rIns="91440" bIns="45720" rtlCol="0" anchor="ctr">
+            <a:normAutofit/>
+          </a:bodyPr>
+          <a:lstStyle>
+            <a:lvl1pPr marL="457189" indent="-457189" algn="l" defTabSz="1219170" rtl="0" eaLnBrk="1" latinLnBrk="0" hangingPunct="1">
+              <a:spcBef>
+                <a:spcPct val="20000"/>
+              </a:spcBef>
+              <a:buFont typeface="Arial" pitchFamily="34" charset="0"/>
+              <a:buChar char="•"/>
+              <a:defRPr sz="4267" kern="1200">
+                <a:solidFill>
+                  <a:schemeClr val="tx1"/>
+                </a:solidFill>
+                <a:latin typeface="+mn-lt"/>
+                <a:ea typeface="+mn-ea"/>
+                <a:cs typeface="+mn-cs"/>
+              </a:defRPr>
+            </a:lvl1pPr>
+            <a:lvl2pPr marL="990575" indent="-380990" algn="l" defTabSz="1219170" rtl="0" eaLnBrk="1" latinLnBrk="0" hangingPunct="1">
+              <a:spcBef>
+                <a:spcPct val="20000"/>
+              </a:spcBef>
+              <a:buFont typeface="Arial" pitchFamily="34" charset="0"/>
+              <a:buChar char="–"/>
+              <a:defRPr sz="3733" kern="1200">
+                <a:solidFill>
+                  <a:schemeClr val="tx1"/>
+                </a:solidFill>
+                <a:latin typeface="+mn-lt"/>
+                <a:ea typeface="+mn-ea"/>
+                <a:cs typeface="+mn-cs"/>
+              </a:defRPr>
+            </a:lvl2pPr>
+            <a:lvl3pPr marL="1523962" indent="-304792" algn="l" defTabSz="1219170" rtl="0" eaLnBrk="1" latinLnBrk="0" hangingPunct="1">
+              <a:spcBef>
+                <a:spcPct val="20000"/>
+              </a:spcBef>
+              <a:buFont typeface="Arial" pitchFamily="34" charset="0"/>
+              <a:buChar char="•"/>
+              <a:defRPr sz="3200" kern="1200">
+                <a:solidFill>
+                  <a:schemeClr val="tx1"/>
+                </a:solidFill>
+                <a:latin typeface="+mn-lt"/>
+                <a:ea typeface="+mn-ea"/>
+                <a:cs typeface="+mn-cs"/>
+              </a:defRPr>
+            </a:lvl3pPr>
+            <a:lvl4pPr marL="2133547" indent="-304792" algn="l" defTabSz="1219170" rtl="0" eaLnBrk="1" latinLnBrk="0" hangingPunct="1">
+              <a:spcBef>
+                <a:spcPct val="20000"/>
+              </a:spcBef>
+              <a:buFont typeface="Arial" pitchFamily="34" charset="0"/>
+              <a:buChar char="–"/>
+              <a:defRPr sz="2667" kern="1200">
+                <a:solidFill>
+                  <a:schemeClr val="tx1"/>
+                </a:solidFill>
+                <a:latin typeface="+mn-lt"/>
+                <a:ea typeface="+mn-ea"/>
+                <a:cs typeface="+mn-cs"/>
+              </a:defRPr>
+            </a:lvl4pPr>
+            <a:lvl5pPr marL="2743131" indent="-304792" algn="l" defTabSz="1219170" rtl="0" eaLnBrk="1" latinLnBrk="0" hangingPunct="1">
+              <a:spcBef>
+                <a:spcPct val="20000"/>
+              </a:spcBef>
+              <a:buFont typeface="Arial" pitchFamily="34" charset="0"/>
+              <a:buChar char="»"/>
+              <a:defRPr sz="2667" kern="1200">
+                <a:solidFill>
+                  <a:schemeClr val="tx1"/>
+                </a:solidFill>
+                <a:latin typeface="+mn-lt"/>
+                <a:ea typeface="+mn-ea"/>
+                <a:cs typeface="+mn-cs"/>
+              </a:defRPr>
+            </a:lvl5pPr>
+            <a:lvl6pPr marL="3352716" indent="-304792" algn="l" defTabSz="1219170" rtl="0" eaLnBrk="1" latinLnBrk="0" hangingPunct="1">
+              <a:spcBef>
+                <a:spcPct val="20000"/>
+              </a:spcBef>
+              <a:buFont typeface="Arial" pitchFamily="34" charset="0"/>
+              <a:buChar char="•"/>
+              <a:defRPr sz="2667" kern="1200">
+                <a:solidFill>
+                  <a:schemeClr val="tx1"/>
+                </a:solidFill>
+                <a:latin typeface="+mn-lt"/>
+                <a:ea typeface="+mn-ea"/>
+                <a:cs typeface="+mn-cs"/>
+              </a:defRPr>
+            </a:lvl6pPr>
+            <a:lvl7pPr marL="3962301" indent="-304792" algn="l" defTabSz="1219170" rtl="0" eaLnBrk="1" latinLnBrk="0" hangingPunct="1">
+              <a:spcBef>
+                <a:spcPct val="20000"/>
+              </a:spcBef>
+              <a:buFont typeface="Arial" pitchFamily="34" charset="0"/>
+              <a:buChar char="•"/>
+              <a:defRPr sz="2667" kern="1200">
+                <a:solidFill>
+                  <a:schemeClr val="tx1"/>
+                </a:solidFill>
+                <a:latin typeface="+mn-lt"/>
+                <a:ea typeface="+mn-ea"/>
+                <a:cs typeface="+mn-cs"/>
+              </a:defRPr>
+            </a:lvl7pPr>
+            <a:lvl8pPr marL="4571886" indent="-304792" algn="l" defTabSz="1219170" rtl="0" eaLnBrk="1" latinLnBrk="0" hangingPunct="1">
+              <a:spcBef>
+                <a:spcPct val="20000"/>
+              </a:spcBef>
+              <a:buFont typeface="Arial" pitchFamily="34" charset="0"/>
+              <a:buChar char="•"/>
+              <a:defRPr sz="2667" kern="1200">
+                <a:solidFill>
+                  <a:schemeClr val="tx1"/>
+                </a:solidFill>
+                <a:latin typeface="+mn-lt"/>
+                <a:ea typeface="+mn-ea"/>
+                <a:cs typeface="+mn-cs"/>
+              </a:defRPr>
+            </a:lvl8pPr>
+            <a:lvl9pPr marL="5181470" indent="-304792" algn="l" defTabSz="1219170" rtl="0" eaLnBrk="1" latinLnBrk="0" hangingPunct="1">
+              <a:spcBef>
+                <a:spcPct val="20000"/>
+              </a:spcBef>
+              <a:buFont typeface="Arial" pitchFamily="34" charset="0"/>
+              <a:buChar char="•"/>
+              <a:defRPr sz="2667" kern="1200">
+                <a:solidFill>
+                  <a:schemeClr val="tx1"/>
+                </a:solidFill>
+                <a:latin typeface="+mn-lt"/>
+                <a:ea typeface="+mn-ea"/>
+                <a:cs typeface="+mn-cs"/>
+              </a:defRPr>
+            </a:lvl9pPr>
+          </a:lstStyle>
+          <a:p>
+            <a:pPr marL="0" indent="0" algn="ctr">
+              <a:buNone/>
+            </a:pPr>
+            <a:r>
+              <a:rPr lang="vi-VN" sz="3600" b="1" dirty="0">
+                <a:solidFill>
+                  <a:srgbClr val="660033"/>
+                </a:solidFill>
+                <a:latin typeface="Calibri" panose="020F0502020204030204" pitchFamily="34" charset="0"/>
+                <a:ea typeface="微軟正黑體" pitchFamily="34" charset="-120"/>
+                <a:cs typeface="Calibri" panose="020F0502020204030204" pitchFamily="34" charset="0"/>
+              </a:rPr>
+              <a:t>Đêm noel, đêm đêm ta xin ơn trên ban hoà bình cho trần thế</a:t>
+            </a:r>
+            <a:endParaRPr lang="en-US" sz="3600" b="1" dirty="0">
+              <a:solidFill>
+                <a:srgbClr val="660033"/>
+              </a:solidFill>
+              <a:latin typeface="Calibri" panose="020F0502020204030204" pitchFamily="34" charset="0"/>
+              <a:ea typeface="微軟正黑體" pitchFamily="34" charset="-120"/>
+              <a:cs typeface="Calibri" panose="020F0502020204030204" pitchFamily="34" charset="0"/>
+            </a:endParaRPr>
+          </a:p>
+        </p:txBody>
+      </p:sp>
+      <p:sp>
+        <p:nvSpPr>
+          <p:cNvPr id="8" name="TextBox 7"/>
+          <p:cNvSpPr txBox="1"/>
+          <p:nvPr/>
+        </p:nvSpPr>
+        <p:spPr>
+          <a:xfrm>
+            <a:off x="0" y="5253203"/>
+            <a:ext cx="12192000" cy="646331"/>
+          </a:xfrm>
+          <a:prstGeom prst="rect">
+            <a:avLst/>
+          </a:prstGeom>
+          <a:noFill/>
+        </p:spPr>
+        <p:txBody>
+          <a:bodyPr wrap="square" rtlCol="0">
+            <a:spAutoFit/>
+          </a:bodyPr>
+          <a:lstStyle/>
+          <a:p>
+            <a:pPr algn="ctr"/>
+            <a:r>
+              <a:rPr lang="en-US" sz="3600" b="1" dirty="0">
+                <a:solidFill>
+                  <a:srgbClr val="000066"/>
+                </a:solidFill>
+                <a:latin typeface="Microsoft JhengHei" panose="020B0604030504040204" pitchFamily="34" charset="-120"/>
+                <a:ea typeface="Microsoft JhengHei" panose="020B0604030504040204" pitchFamily="34" charset="-120"/>
+              </a:rPr>
+              <a:t>( </a:t>
+            </a:r>
+            <a:r>
+              <a:rPr lang="zh-CN" altLang="en-US" sz="3600" b="1" dirty="0">
+                <a:solidFill>
+                  <a:srgbClr val="000066"/>
+                </a:solidFill>
+                <a:latin typeface="Microsoft JhengHei" panose="020B0604030504040204" pitchFamily="34" charset="-120"/>
+                <a:ea typeface="Microsoft JhengHei" panose="020B0604030504040204" pitchFamily="34" charset="-120"/>
+              </a:rPr>
+              <a:t>副歌</a:t>
+            </a:r>
+            <a:r>
+              <a:rPr lang="en-US" sz="3600" b="1" dirty="0">
+                <a:solidFill>
+                  <a:srgbClr val="000066"/>
+                </a:solidFill>
+                <a:latin typeface="Microsoft JhengHei" panose="020B0604030504040204" pitchFamily="34" charset="-120"/>
+                <a:ea typeface="Microsoft JhengHei" panose="020B0604030504040204" pitchFamily="34" charset="-120"/>
+              </a:rPr>
+              <a:t> )</a:t>
+            </a:r>
+            <a:endParaRPr lang="vi-VN" sz="3600" b="1" dirty="0">
+              <a:solidFill>
+                <a:srgbClr val="000066"/>
+              </a:solidFill>
+              <a:ea typeface="Microsoft JhengHei" panose="020B0604030504040204" pitchFamily="34" charset="-120"/>
+            </a:endParaRPr>
+          </a:p>
+        </p:txBody>
+      </p:sp>
+    </p:spTree>
+    <p:extLst>
+      <p:ext uri="{BB962C8B-B14F-4D97-AF65-F5344CB8AC3E}">
+        <p14:creationId xmlns:p14="http://schemas.microsoft.com/office/powerpoint/2010/main" val="3732715540"/>
+      </p:ext>
+    </p:extLst>
+  </p:cSld>
+  <p:clrMapOvr>
+    <a:masterClrMapping/>
+  </p:clrMapOvr>
+</p:sld>
+</file>
+
+<file path=ppt/slides/slide12.xml><?xml version="1.0" encoding="utf-8"?>
+<p:sld xmlns:a="http://schemas.openxmlformats.org/drawingml/2006/main" xmlns:r="http://schemas.openxmlformats.org/officeDocument/2006/relationships" xmlns:p="http://schemas.openxmlformats.org/presentationml/2006/main">
+  <p:cSld>
+    <p:spTree>
+      <p:nvGrpSpPr>
+        <p:cNvPr id="1" name=""/>
+        <p:cNvGrpSpPr/>
+        <p:nvPr/>
+      </p:nvGrpSpPr>
+      <p:grpSpPr>
+        <a:xfrm>
+          <a:off x="0" y="0"/>
+          <a:ext cx="0" cy="0"/>
+          <a:chOff x="0" y="0"/>
+          <a:chExt cx="0" cy="0"/>
+        </a:xfrm>
+      </p:grpSpPr>
+      <p:sp>
+        <p:nvSpPr>
+          <p:cNvPr id="6" name="內容版面配置區 4"/>
+          <p:cNvSpPr>
+            <a:spLocks noGrp="1"/>
+          </p:cNvSpPr>
+          <p:nvPr>
+            <p:ph idx="1"/>
+          </p:nvPr>
+        </p:nvSpPr>
+        <p:spPr>
+          <a:xfrm>
+            <a:off x="0" y="2167981"/>
+            <a:ext cx="12192000" cy="1318225"/>
+          </a:xfrm>
+        </p:spPr>
+        <p:txBody>
+          <a:bodyPr anchor="ctr">
+            <a:normAutofit/>
+          </a:bodyPr>
+          <a:lstStyle/>
+          <a:p>
+            <a:pPr algn="ctr">
+              <a:buNone/>
+            </a:pPr>
+            <a:r>
+              <a:rPr lang="zh-TW" altLang="en-US" sz="6400" b="1" dirty="0">
+                <a:solidFill>
+                  <a:srgbClr val="000066"/>
+                </a:solidFill>
+                <a:latin typeface="微軟正黑體" pitchFamily="34" charset="-120"/>
+                <a:ea typeface="微軟正黑體" pitchFamily="34" charset="-120"/>
+              </a:rPr>
+              <a:t>好開心  真開心  主恩滿我心</a:t>
+            </a:r>
+            <a:endParaRPr lang="en-US" altLang="zh-CN" sz="6400" b="1" dirty="0">
+              <a:solidFill>
+                <a:srgbClr val="000066"/>
+              </a:solidFill>
+              <a:latin typeface="微軟正黑體" pitchFamily="34" charset="-120"/>
+              <a:ea typeface="微軟正黑體" pitchFamily="34" charset="-120"/>
+            </a:endParaRPr>
+          </a:p>
+        </p:txBody>
+      </p:sp>
+      <p:sp>
+        <p:nvSpPr>
+          <p:cNvPr id="7" name="內容版面配置區 4"/>
+          <p:cNvSpPr txBox="1">
+            <a:spLocks/>
+          </p:cNvSpPr>
+          <p:nvPr/>
+        </p:nvSpPr>
+        <p:spPr>
+          <a:xfrm>
+            <a:off x="0" y="3117530"/>
+            <a:ext cx="12192000" cy="1318225"/>
+          </a:xfrm>
+          <a:prstGeom prst="rect">
+            <a:avLst/>
+          </a:prstGeom>
+        </p:spPr>
+        <p:txBody>
+          <a:bodyPr vert="horz" lIns="91440" tIns="45720" rIns="91440" bIns="45720" rtlCol="0" anchor="ctr">
+            <a:normAutofit/>
+          </a:bodyPr>
+          <a:lstStyle>
+            <a:lvl1pPr marL="457189" indent="-457189" algn="l" defTabSz="1219170" rtl="0" eaLnBrk="1" latinLnBrk="0" hangingPunct="1">
+              <a:spcBef>
+                <a:spcPct val="20000"/>
+              </a:spcBef>
+              <a:buFont typeface="Arial" pitchFamily="34" charset="0"/>
+              <a:buChar char="•"/>
+              <a:defRPr sz="4267" kern="1200">
+                <a:solidFill>
+                  <a:schemeClr val="tx1"/>
+                </a:solidFill>
+                <a:latin typeface="+mn-lt"/>
+                <a:ea typeface="+mn-ea"/>
+                <a:cs typeface="+mn-cs"/>
+              </a:defRPr>
+            </a:lvl1pPr>
+            <a:lvl2pPr marL="990575" indent="-380990" algn="l" defTabSz="1219170" rtl="0" eaLnBrk="1" latinLnBrk="0" hangingPunct="1">
+              <a:spcBef>
+                <a:spcPct val="20000"/>
+              </a:spcBef>
+              <a:buFont typeface="Arial" pitchFamily="34" charset="0"/>
+              <a:buChar char="–"/>
+              <a:defRPr sz="3733" kern="1200">
+                <a:solidFill>
+                  <a:schemeClr val="tx1"/>
+                </a:solidFill>
+                <a:latin typeface="+mn-lt"/>
+                <a:ea typeface="+mn-ea"/>
+                <a:cs typeface="+mn-cs"/>
+              </a:defRPr>
+            </a:lvl2pPr>
+            <a:lvl3pPr marL="1523962" indent="-304792" algn="l" defTabSz="1219170" rtl="0" eaLnBrk="1" latinLnBrk="0" hangingPunct="1">
+              <a:spcBef>
+                <a:spcPct val="20000"/>
+              </a:spcBef>
+              <a:buFont typeface="Arial" pitchFamily="34" charset="0"/>
+              <a:buChar char="•"/>
+              <a:defRPr sz="3200" kern="1200">
+                <a:solidFill>
+                  <a:schemeClr val="tx1"/>
+                </a:solidFill>
+                <a:latin typeface="+mn-lt"/>
+                <a:ea typeface="+mn-ea"/>
+                <a:cs typeface="+mn-cs"/>
+              </a:defRPr>
+            </a:lvl3pPr>
+            <a:lvl4pPr marL="2133547" indent="-304792" algn="l" defTabSz="1219170" rtl="0" eaLnBrk="1" latinLnBrk="0" hangingPunct="1">
+              <a:spcBef>
+                <a:spcPct val="20000"/>
+              </a:spcBef>
+              <a:buFont typeface="Arial" pitchFamily="34" charset="0"/>
+              <a:buChar char="–"/>
+              <a:defRPr sz="2667" kern="1200">
+                <a:solidFill>
+                  <a:schemeClr val="tx1"/>
+                </a:solidFill>
+                <a:latin typeface="+mn-lt"/>
+                <a:ea typeface="+mn-ea"/>
+                <a:cs typeface="+mn-cs"/>
+              </a:defRPr>
+            </a:lvl4pPr>
+            <a:lvl5pPr marL="2743131" indent="-304792" algn="l" defTabSz="1219170" rtl="0" eaLnBrk="1" latinLnBrk="0" hangingPunct="1">
+              <a:spcBef>
+                <a:spcPct val="20000"/>
+              </a:spcBef>
+              <a:buFont typeface="Arial" pitchFamily="34" charset="0"/>
+              <a:buChar char="»"/>
+              <a:defRPr sz="2667" kern="1200">
+                <a:solidFill>
+                  <a:schemeClr val="tx1"/>
+                </a:solidFill>
+                <a:latin typeface="+mn-lt"/>
+                <a:ea typeface="+mn-ea"/>
+                <a:cs typeface="+mn-cs"/>
+              </a:defRPr>
+            </a:lvl5pPr>
+            <a:lvl6pPr marL="3352716" indent="-304792" algn="l" defTabSz="1219170" rtl="0" eaLnBrk="1" latinLnBrk="0" hangingPunct="1">
+              <a:spcBef>
+                <a:spcPct val="20000"/>
+              </a:spcBef>
+              <a:buFont typeface="Arial" pitchFamily="34" charset="0"/>
+              <a:buChar char="•"/>
+              <a:defRPr sz="2667" kern="1200">
+                <a:solidFill>
+                  <a:schemeClr val="tx1"/>
+                </a:solidFill>
+                <a:latin typeface="+mn-lt"/>
+                <a:ea typeface="+mn-ea"/>
+                <a:cs typeface="+mn-cs"/>
+              </a:defRPr>
+            </a:lvl6pPr>
+            <a:lvl7pPr marL="3962301" indent="-304792" algn="l" defTabSz="1219170" rtl="0" eaLnBrk="1" latinLnBrk="0" hangingPunct="1">
+              <a:spcBef>
+                <a:spcPct val="20000"/>
+              </a:spcBef>
+              <a:buFont typeface="Arial" pitchFamily="34" charset="0"/>
+              <a:buChar char="•"/>
+              <a:defRPr sz="2667" kern="1200">
+                <a:solidFill>
+                  <a:schemeClr val="tx1"/>
+                </a:solidFill>
+                <a:latin typeface="+mn-lt"/>
+                <a:ea typeface="+mn-ea"/>
+                <a:cs typeface="+mn-cs"/>
+              </a:defRPr>
+            </a:lvl7pPr>
+            <a:lvl8pPr marL="4571886" indent="-304792" algn="l" defTabSz="1219170" rtl="0" eaLnBrk="1" latinLnBrk="0" hangingPunct="1">
+              <a:spcBef>
+                <a:spcPct val="20000"/>
+              </a:spcBef>
+              <a:buFont typeface="Arial" pitchFamily="34" charset="0"/>
+              <a:buChar char="•"/>
+              <a:defRPr sz="2667" kern="1200">
+                <a:solidFill>
+                  <a:schemeClr val="tx1"/>
+                </a:solidFill>
+                <a:latin typeface="+mn-lt"/>
+                <a:ea typeface="+mn-ea"/>
+                <a:cs typeface="+mn-cs"/>
+              </a:defRPr>
+            </a:lvl8pPr>
+            <a:lvl9pPr marL="5181470" indent="-304792" algn="l" defTabSz="1219170" rtl="0" eaLnBrk="1" latinLnBrk="0" hangingPunct="1">
+              <a:spcBef>
+                <a:spcPct val="20000"/>
+              </a:spcBef>
+              <a:buFont typeface="Arial" pitchFamily="34" charset="0"/>
+              <a:buChar char="•"/>
+              <a:defRPr sz="2667" kern="1200">
+                <a:solidFill>
+                  <a:schemeClr val="tx1"/>
+                </a:solidFill>
+                <a:latin typeface="+mn-lt"/>
+                <a:ea typeface="+mn-ea"/>
+                <a:cs typeface="+mn-cs"/>
+              </a:defRPr>
+            </a:lvl9pPr>
+          </a:lstStyle>
+          <a:p>
+            <a:pPr marL="0" indent="0" algn="ctr">
+              <a:buNone/>
+            </a:pPr>
+            <a:r>
+              <a:rPr lang="vi-VN" sz="4000" b="1" dirty="0">
+                <a:solidFill>
+                  <a:srgbClr val="660033"/>
+                </a:solidFill>
+                <a:latin typeface="Calibri" panose="020F0502020204030204" pitchFamily="34" charset="0"/>
+                <a:ea typeface="微軟正黑體" pitchFamily="34" charset="-120"/>
+                <a:cs typeface="Calibri" panose="020F0502020204030204" pitchFamily="34" charset="0"/>
+              </a:rPr>
+              <a:t>Đêm Noel chuông vang lên chuông giáo đường vang lên</a:t>
+            </a:r>
+            <a:endParaRPr lang="en-US" sz="4000" b="1" dirty="0">
+              <a:solidFill>
+                <a:srgbClr val="660033"/>
+              </a:solidFill>
+              <a:latin typeface="Calibri" panose="020F0502020204030204" pitchFamily="34" charset="0"/>
+              <a:ea typeface="微軟正黑體" pitchFamily="34" charset="-120"/>
+              <a:cs typeface="Calibri" panose="020F0502020204030204" pitchFamily="34" charset="0"/>
+            </a:endParaRPr>
+          </a:p>
+        </p:txBody>
+      </p:sp>
+      <p:sp>
+        <p:nvSpPr>
+          <p:cNvPr id="8" name="TextBox 7"/>
+          <p:cNvSpPr txBox="1"/>
+          <p:nvPr/>
+        </p:nvSpPr>
+        <p:spPr>
+          <a:xfrm>
+            <a:off x="0" y="5253203"/>
+            <a:ext cx="12192000" cy="646331"/>
+          </a:xfrm>
+          <a:prstGeom prst="rect">
+            <a:avLst/>
+          </a:prstGeom>
+          <a:noFill/>
+        </p:spPr>
+        <p:txBody>
+          <a:bodyPr wrap="square" rtlCol="0">
+            <a:spAutoFit/>
+          </a:bodyPr>
+          <a:lstStyle/>
+          <a:p>
+            <a:pPr algn="ctr"/>
+            <a:r>
+              <a:rPr lang="en-US" sz="3600" b="1" dirty="0">
+                <a:solidFill>
+                  <a:srgbClr val="000066"/>
+                </a:solidFill>
+                <a:latin typeface="Microsoft JhengHei" panose="020B0604030504040204" pitchFamily="34" charset="-120"/>
+                <a:ea typeface="Microsoft JhengHei" panose="020B0604030504040204" pitchFamily="34" charset="-120"/>
+              </a:rPr>
+              <a:t>( </a:t>
+            </a:r>
+            <a:r>
+              <a:rPr lang="zh-CN" altLang="en-US" sz="3600" b="1" dirty="0">
+                <a:solidFill>
+                  <a:srgbClr val="000066"/>
+                </a:solidFill>
+                <a:latin typeface="Microsoft JhengHei" panose="020B0604030504040204" pitchFamily="34" charset="-120"/>
+                <a:ea typeface="Microsoft JhengHei" panose="020B0604030504040204" pitchFamily="34" charset="-120"/>
+              </a:rPr>
+              <a:t>副歌</a:t>
+            </a:r>
+            <a:r>
+              <a:rPr lang="en-US" sz="3600" b="1" dirty="0">
+                <a:solidFill>
+                  <a:srgbClr val="000066"/>
+                </a:solidFill>
+                <a:latin typeface="Microsoft JhengHei" panose="020B0604030504040204" pitchFamily="34" charset="-120"/>
+                <a:ea typeface="Microsoft JhengHei" panose="020B0604030504040204" pitchFamily="34" charset="-120"/>
+              </a:rPr>
+              <a:t> )</a:t>
+            </a:r>
+            <a:endParaRPr lang="vi-VN" sz="3600" b="1" dirty="0">
+              <a:solidFill>
+                <a:srgbClr val="000066"/>
+              </a:solidFill>
+              <a:ea typeface="Microsoft JhengHei" panose="020B0604030504040204" pitchFamily="34" charset="-120"/>
+            </a:endParaRPr>
+          </a:p>
+        </p:txBody>
+      </p:sp>
+    </p:spTree>
+    <p:extLst>
+      <p:ext uri="{BB962C8B-B14F-4D97-AF65-F5344CB8AC3E}">
+        <p14:creationId xmlns:p14="http://schemas.microsoft.com/office/powerpoint/2010/main" val="1611647430"/>
+      </p:ext>
+    </p:extLst>
+  </p:cSld>
+  <p:clrMapOvr>
+    <a:masterClrMapping/>
+  </p:clrMapOvr>
+</p:sld>
+</file>
+
+<file path=ppt/slides/slide13.xml><?xml version="1.0" encoding="utf-8"?>
+<p:sld xmlns:a="http://schemas.openxmlformats.org/drawingml/2006/main" xmlns:r="http://schemas.openxmlformats.org/officeDocument/2006/relationships" xmlns:p="http://schemas.openxmlformats.org/presentationml/2006/main">
+  <p:cSld>
+    <p:spTree>
+      <p:nvGrpSpPr>
+        <p:cNvPr id="1" name=""/>
+        <p:cNvGrpSpPr/>
+        <p:nvPr/>
+      </p:nvGrpSpPr>
+      <p:grpSpPr>
+        <a:xfrm>
+          <a:off x="0" y="0"/>
+          <a:ext cx="0" cy="0"/>
+          <a:chOff x="0" y="0"/>
+          <a:chExt cx="0" cy="0"/>
+        </a:xfrm>
+      </p:grpSpPr>
+      <p:sp>
+        <p:nvSpPr>
+          <p:cNvPr id="6" name="內容版面配置區 4"/>
+          <p:cNvSpPr>
+            <a:spLocks noGrp="1"/>
+          </p:cNvSpPr>
+          <p:nvPr>
+            <p:ph idx="1"/>
+          </p:nvPr>
+        </p:nvSpPr>
+        <p:spPr>
+          <a:xfrm>
+            <a:off x="0" y="2167981"/>
+            <a:ext cx="12192000" cy="1318225"/>
+          </a:xfrm>
+        </p:spPr>
+        <p:txBody>
+          <a:bodyPr anchor="ctr">
+            <a:normAutofit/>
+          </a:bodyPr>
+          <a:lstStyle/>
+          <a:p>
+            <a:pPr algn="ctr">
+              <a:buNone/>
+            </a:pPr>
+            <a:r>
+              <a:rPr lang="zh-TW" altLang="en-US" sz="6400" b="1" dirty="0">
+                <a:solidFill>
+                  <a:srgbClr val="000066"/>
+                </a:solidFill>
+                <a:latin typeface="微軟正黑體" pitchFamily="34" charset="-120"/>
+                <a:ea typeface="微軟正黑體" pitchFamily="34" charset="-120"/>
+              </a:rPr>
+              <a:t>你與我  快樂頌  願天天一起唱</a:t>
+            </a:r>
+            <a:endParaRPr lang="en-US" altLang="zh-CN" sz="6400" b="1" dirty="0">
+              <a:solidFill>
+                <a:srgbClr val="000066"/>
+              </a:solidFill>
+              <a:latin typeface="微軟正黑體" pitchFamily="34" charset="-120"/>
+              <a:ea typeface="微軟正黑體" pitchFamily="34" charset="-120"/>
+            </a:endParaRPr>
+          </a:p>
+        </p:txBody>
+      </p:sp>
+      <p:sp>
+        <p:nvSpPr>
+          <p:cNvPr id="7" name="內容版面配置區 4"/>
+          <p:cNvSpPr txBox="1">
+            <a:spLocks/>
+          </p:cNvSpPr>
+          <p:nvPr/>
+        </p:nvSpPr>
+        <p:spPr>
+          <a:xfrm>
+            <a:off x="0" y="3117530"/>
+            <a:ext cx="12192000" cy="1318225"/>
+          </a:xfrm>
+          <a:prstGeom prst="rect">
+            <a:avLst/>
+          </a:prstGeom>
+        </p:spPr>
+        <p:txBody>
+          <a:bodyPr vert="horz" lIns="91440" tIns="45720" rIns="91440" bIns="45720" rtlCol="0" anchor="ctr">
+            <a:normAutofit/>
+          </a:bodyPr>
+          <a:lstStyle>
+            <a:lvl1pPr marL="457189" indent="-457189" algn="l" defTabSz="1219170" rtl="0" eaLnBrk="1" latinLnBrk="0" hangingPunct="1">
+              <a:spcBef>
+                <a:spcPct val="20000"/>
+              </a:spcBef>
+              <a:buFont typeface="Arial" pitchFamily="34" charset="0"/>
+              <a:buChar char="•"/>
+              <a:defRPr sz="4267" kern="1200">
+                <a:solidFill>
+                  <a:schemeClr val="tx1"/>
+                </a:solidFill>
+                <a:latin typeface="+mn-lt"/>
+                <a:ea typeface="+mn-ea"/>
+                <a:cs typeface="+mn-cs"/>
+              </a:defRPr>
+            </a:lvl1pPr>
+            <a:lvl2pPr marL="990575" indent="-380990" algn="l" defTabSz="1219170" rtl="0" eaLnBrk="1" latinLnBrk="0" hangingPunct="1">
+              <a:spcBef>
+                <a:spcPct val="20000"/>
+              </a:spcBef>
+              <a:buFont typeface="Arial" pitchFamily="34" charset="0"/>
+              <a:buChar char="–"/>
+              <a:defRPr sz="3733" kern="1200">
+                <a:solidFill>
+                  <a:schemeClr val="tx1"/>
+                </a:solidFill>
+                <a:latin typeface="+mn-lt"/>
+                <a:ea typeface="+mn-ea"/>
+                <a:cs typeface="+mn-cs"/>
+              </a:defRPr>
+            </a:lvl2pPr>
+            <a:lvl3pPr marL="1523962" indent="-304792" algn="l" defTabSz="1219170" rtl="0" eaLnBrk="1" latinLnBrk="0" hangingPunct="1">
+              <a:spcBef>
+                <a:spcPct val="20000"/>
+              </a:spcBef>
+              <a:buFont typeface="Arial" pitchFamily="34" charset="0"/>
+              <a:buChar char="•"/>
+              <a:defRPr sz="3200" kern="1200">
+                <a:solidFill>
+                  <a:schemeClr val="tx1"/>
+                </a:solidFill>
+                <a:latin typeface="+mn-lt"/>
+                <a:ea typeface="+mn-ea"/>
+                <a:cs typeface="+mn-cs"/>
+              </a:defRPr>
+            </a:lvl3pPr>
+            <a:lvl4pPr marL="2133547" indent="-304792" algn="l" defTabSz="1219170" rtl="0" eaLnBrk="1" latinLnBrk="0" hangingPunct="1">
+              <a:spcBef>
+                <a:spcPct val="20000"/>
+              </a:spcBef>
+              <a:buFont typeface="Arial" pitchFamily="34" charset="0"/>
+              <a:buChar char="–"/>
+              <a:defRPr sz="2667" kern="1200">
+                <a:solidFill>
+                  <a:schemeClr val="tx1"/>
+                </a:solidFill>
+                <a:latin typeface="+mn-lt"/>
+                <a:ea typeface="+mn-ea"/>
+                <a:cs typeface="+mn-cs"/>
+              </a:defRPr>
+            </a:lvl4pPr>
+            <a:lvl5pPr marL="2743131" indent="-304792" algn="l" defTabSz="1219170" rtl="0" eaLnBrk="1" latinLnBrk="0" hangingPunct="1">
+              <a:spcBef>
+                <a:spcPct val="20000"/>
+              </a:spcBef>
+              <a:buFont typeface="Arial" pitchFamily="34" charset="0"/>
+              <a:buChar char="»"/>
+              <a:defRPr sz="2667" kern="1200">
+                <a:solidFill>
+                  <a:schemeClr val="tx1"/>
+                </a:solidFill>
+                <a:latin typeface="+mn-lt"/>
+                <a:ea typeface="+mn-ea"/>
+                <a:cs typeface="+mn-cs"/>
+              </a:defRPr>
+            </a:lvl5pPr>
+            <a:lvl6pPr marL="3352716" indent="-304792" algn="l" defTabSz="1219170" rtl="0" eaLnBrk="1" latinLnBrk="0" hangingPunct="1">
+              <a:spcBef>
+                <a:spcPct val="20000"/>
+              </a:spcBef>
+              <a:buFont typeface="Arial" pitchFamily="34" charset="0"/>
+              <a:buChar char="•"/>
+              <a:defRPr sz="2667" kern="1200">
+                <a:solidFill>
+                  <a:schemeClr val="tx1"/>
+                </a:solidFill>
+                <a:latin typeface="+mn-lt"/>
+                <a:ea typeface="+mn-ea"/>
+                <a:cs typeface="+mn-cs"/>
+              </a:defRPr>
+            </a:lvl6pPr>
+            <a:lvl7pPr marL="3962301" indent="-304792" algn="l" defTabSz="1219170" rtl="0" eaLnBrk="1" latinLnBrk="0" hangingPunct="1">
+              <a:spcBef>
+                <a:spcPct val="20000"/>
+              </a:spcBef>
+              <a:buFont typeface="Arial" pitchFamily="34" charset="0"/>
+              <a:buChar char="•"/>
+              <a:defRPr sz="2667" kern="1200">
+                <a:solidFill>
+                  <a:schemeClr val="tx1"/>
+                </a:solidFill>
+                <a:latin typeface="+mn-lt"/>
+                <a:ea typeface="+mn-ea"/>
+                <a:cs typeface="+mn-cs"/>
+              </a:defRPr>
+            </a:lvl7pPr>
+            <a:lvl8pPr marL="4571886" indent="-304792" algn="l" defTabSz="1219170" rtl="0" eaLnBrk="1" latinLnBrk="0" hangingPunct="1">
+              <a:spcBef>
+                <a:spcPct val="20000"/>
+              </a:spcBef>
+              <a:buFont typeface="Arial" pitchFamily="34" charset="0"/>
+              <a:buChar char="•"/>
+              <a:defRPr sz="2667" kern="1200">
+                <a:solidFill>
+                  <a:schemeClr val="tx1"/>
+                </a:solidFill>
+                <a:latin typeface="+mn-lt"/>
+                <a:ea typeface="+mn-ea"/>
+                <a:cs typeface="+mn-cs"/>
+              </a:defRPr>
+            </a:lvl8pPr>
+            <a:lvl9pPr marL="5181470" indent="-304792" algn="l" defTabSz="1219170" rtl="0" eaLnBrk="1" latinLnBrk="0" hangingPunct="1">
+              <a:spcBef>
+                <a:spcPct val="20000"/>
+              </a:spcBef>
+              <a:buFont typeface="Arial" pitchFamily="34" charset="0"/>
+              <a:buChar char="•"/>
+              <a:defRPr sz="2667" kern="1200">
+                <a:solidFill>
+                  <a:schemeClr val="tx1"/>
+                </a:solidFill>
+                <a:latin typeface="+mn-lt"/>
+                <a:ea typeface="+mn-ea"/>
+                <a:cs typeface="+mn-cs"/>
+              </a:defRPr>
+            </a:lvl9pPr>
+          </a:lstStyle>
+          <a:p>
+            <a:pPr marL="0" indent="0" algn="ctr">
+              <a:buNone/>
+            </a:pPr>
+            <a:r>
+              <a:rPr lang="vi-VN" sz="4400" b="1" dirty="0">
+                <a:solidFill>
+                  <a:srgbClr val="660033"/>
+                </a:solidFill>
+                <a:latin typeface="Calibri" panose="020F0502020204030204" pitchFamily="34" charset="0"/>
+                <a:ea typeface="微軟正黑體" pitchFamily="34" charset="-120"/>
+                <a:cs typeface="Calibri" panose="020F0502020204030204" pitchFamily="34" charset="0"/>
+              </a:rPr>
+              <a:t>Đêm Noel, đêm Noel, ta hãy chúc nhau an bình</a:t>
+            </a:r>
+            <a:endParaRPr lang="en-US" sz="4400" b="1" dirty="0">
+              <a:solidFill>
+                <a:srgbClr val="660033"/>
+              </a:solidFill>
+              <a:latin typeface="Calibri" panose="020F0502020204030204" pitchFamily="34" charset="0"/>
+              <a:ea typeface="微軟正黑體" pitchFamily="34" charset="-120"/>
+              <a:cs typeface="Calibri" panose="020F0502020204030204" pitchFamily="34" charset="0"/>
+            </a:endParaRPr>
+          </a:p>
+        </p:txBody>
+      </p:sp>
+      <p:sp>
+        <p:nvSpPr>
+          <p:cNvPr id="8" name="TextBox 7"/>
+          <p:cNvSpPr txBox="1"/>
+          <p:nvPr/>
+        </p:nvSpPr>
+        <p:spPr>
+          <a:xfrm>
+            <a:off x="0" y="5253203"/>
+            <a:ext cx="12192000" cy="646331"/>
+          </a:xfrm>
+          <a:prstGeom prst="rect">
+            <a:avLst/>
+          </a:prstGeom>
+          <a:noFill/>
+        </p:spPr>
+        <p:txBody>
+          <a:bodyPr wrap="square" rtlCol="0">
+            <a:spAutoFit/>
+          </a:bodyPr>
+          <a:lstStyle/>
+          <a:p>
+            <a:pPr algn="ctr"/>
+            <a:r>
+              <a:rPr lang="en-US" sz="3600" b="1" dirty="0">
+                <a:solidFill>
+                  <a:srgbClr val="000066"/>
+                </a:solidFill>
+                <a:latin typeface="Microsoft JhengHei" panose="020B0604030504040204" pitchFamily="34" charset="-120"/>
+                <a:ea typeface="Microsoft JhengHei" panose="020B0604030504040204" pitchFamily="34" charset="-120"/>
+              </a:rPr>
+              <a:t>( </a:t>
+            </a:r>
+            <a:r>
+              <a:rPr lang="zh-CN" altLang="en-US" sz="3600" b="1" dirty="0">
+                <a:solidFill>
+                  <a:srgbClr val="000066"/>
+                </a:solidFill>
+                <a:latin typeface="Microsoft JhengHei" panose="020B0604030504040204" pitchFamily="34" charset="-120"/>
+                <a:ea typeface="Microsoft JhengHei" panose="020B0604030504040204" pitchFamily="34" charset="-120"/>
+              </a:rPr>
+              <a:t>副歌</a:t>
+            </a:r>
+            <a:r>
+              <a:rPr lang="en-US" sz="3600" b="1" dirty="0">
+                <a:solidFill>
+                  <a:srgbClr val="000066"/>
+                </a:solidFill>
+                <a:latin typeface="Microsoft JhengHei" panose="020B0604030504040204" pitchFamily="34" charset="-120"/>
+                <a:ea typeface="Microsoft JhengHei" panose="020B0604030504040204" pitchFamily="34" charset="-120"/>
+              </a:rPr>
+              <a:t> )</a:t>
+            </a:r>
+            <a:endParaRPr lang="vi-VN" sz="3600" b="1" dirty="0">
+              <a:solidFill>
+                <a:srgbClr val="000066"/>
+              </a:solidFill>
+              <a:ea typeface="Microsoft JhengHei" panose="020B0604030504040204" pitchFamily="34" charset="-120"/>
+            </a:endParaRPr>
+          </a:p>
+        </p:txBody>
+      </p:sp>
+    </p:spTree>
+    <p:extLst>
+      <p:ext uri="{BB962C8B-B14F-4D97-AF65-F5344CB8AC3E}">
+        <p14:creationId xmlns:p14="http://schemas.microsoft.com/office/powerpoint/2010/main" val="599047401"/>
+      </p:ext>
+    </p:extLst>
+  </p:cSld>
+  <p:clrMapOvr>
+    <a:masterClrMapping/>
+  </p:clrMapOvr>
+</p:sld>
+</file>
+
 <file path=ppt/slides/slide2.xml><?xml version="1.0" encoding="utf-8"?>
 <p:sld xmlns:a="http://schemas.openxmlformats.org/drawingml/2006/main" xmlns:r="http://schemas.openxmlformats.org/officeDocument/2006/relationships" xmlns:p="http://schemas.openxmlformats.org/presentationml/2006/main">
   <p:cSld>
@@ -3310,7 +4598,7 @@
                 <a:latin typeface="微軟正黑體" pitchFamily="34" charset="-120"/>
                 <a:ea typeface="微軟正黑體" pitchFamily="34" charset="-120"/>
               </a:rPr>
-              <a:t>神捨身愛人  來將真愛贈</a:t>
+              <a:t>神捨身愛人</a:t>
             </a:r>
             <a:endParaRPr lang="en-US" altLang="zh-CN" sz="6400" b="1" dirty="0">
               <a:solidFill>
@@ -3485,7 +4773,7 @@
               <a:buNone/>
             </a:pPr>
             <a:r>
-              <a:rPr lang="vi-VN" sz="3600" b="1" dirty="0">
+              <a:rPr lang="vi-VN" sz="4400" b="1" dirty="0">
                 <a:solidFill>
                   <a:srgbClr val="660033"/>
                 </a:solidFill>
@@ -3493,9 +4781,9 @@
                 <a:ea typeface="微軟正黑體" pitchFamily="34" charset="-120"/>
                 <a:cs typeface="Calibri" panose="020F0502020204030204" pitchFamily="34" charset="0"/>
               </a:rPr>
-              <a:t>Mừng ngày chúa sinh ra đời, nào cùng nắm tay tươi cười</a:t>
-            </a:r>
-            <a:endParaRPr lang="en-US" sz="3600" b="1" dirty="0">
+              <a:t>Mừng ngày chúa sinh ra đời</a:t>
+            </a:r>
+            <a:endParaRPr lang="en-US" sz="4400" b="1" dirty="0">
               <a:solidFill>
                 <a:srgbClr val="660033"/>
               </a:solidFill>
@@ -3590,7 +4878,13 @@
   <p:cSld>
     <p:spTree>
       <p:nvGrpSpPr>
-        <p:cNvPr id="1" name=""/>
+        <p:cNvPr id="1" name="">
+          <a:extLst>
+            <a:ext uri="{FF2B5EF4-FFF2-40B4-BE49-F238E27FC236}">
+              <a16:creationId xmlns:a16="http://schemas.microsoft.com/office/drawing/2014/main" id="{32D28C1C-EA56-6785-4C1D-455D6844AFB8}"/>
+            </a:ext>
+          </a:extLst>
+        </p:cNvPr>
         <p:cNvGrpSpPr/>
         <p:nvPr/>
       </p:nvGrpSpPr>
@@ -3604,7 +4898,13 @@
       </p:grpSpPr>
       <p:sp>
         <p:nvSpPr>
-          <p:cNvPr id="6" name="內容版面配置區 4"/>
+          <p:cNvPr id="6" name="內容版面配置區 4">
+            <a:extLst>
+              <a:ext uri="{FF2B5EF4-FFF2-40B4-BE49-F238E27FC236}">
+                <a16:creationId xmlns:a16="http://schemas.microsoft.com/office/drawing/2014/main" id="{4C07A782-EC88-9EB2-76B4-FDF2BE68FA13}"/>
+              </a:ext>
+            </a:extLst>
+          </p:cNvPr>
           <p:cNvSpPr>
             <a:spLocks noGrp="1"/>
           </p:cNvSpPr>
@@ -3635,7 +4935,7 @@
                 <a:latin typeface="微軟正黑體" pitchFamily="34" charset="-120"/>
                 <a:ea typeface="微軟正黑體" pitchFamily="34" charset="-120"/>
               </a:rPr>
-              <a:t>耶穌甘替罪  改寫死與生</a:t>
+              <a:t>來將真愛贈</a:t>
             </a:r>
             <a:endParaRPr lang="en-US" altLang="zh-CN" sz="6400" b="1" dirty="0">
               <a:solidFill>
@@ -3649,7 +4949,13 @@
       </p:sp>
       <p:sp>
         <p:nvSpPr>
-          <p:cNvPr id="7" name="內容版面配置區 4"/>
+          <p:cNvPr id="7" name="內容版面配置區 4">
+            <a:extLst>
+              <a:ext uri="{FF2B5EF4-FFF2-40B4-BE49-F238E27FC236}">
+                <a16:creationId xmlns:a16="http://schemas.microsoft.com/office/drawing/2014/main" id="{F8D29C0D-A4B7-7E42-BAFF-91AB3D8F6468}"/>
+              </a:ext>
+            </a:extLst>
+          </p:cNvPr>
           <p:cNvSpPr txBox="1">
             <a:spLocks/>
           </p:cNvSpPr>
@@ -3810,7 +5116,7 @@
               <a:buNone/>
             </a:pPr>
             <a:r>
-              <a:rPr lang="vi-VN" sz="3600" b="1" dirty="0">
+              <a:rPr lang="en-US" sz="4400" b="1" dirty="0">
                 <a:solidFill>
                   <a:srgbClr val="660033"/>
                 </a:solidFill>
@@ -3818,9 +5124,20 @@
                 <a:ea typeface="微軟正黑體" pitchFamily="34" charset="-120"/>
                 <a:cs typeface="Calibri" panose="020F0502020204030204" pitchFamily="34" charset="0"/>
               </a:rPr>
-              <a:t>Hoà bình đến cho muôn người, cùng cất tiếng ca mừng vui</a:t>
-            </a:r>
-            <a:endParaRPr lang="en-US" sz="3600" b="1" dirty="0">
+              <a:t>N</a:t>
+            </a:r>
+            <a:r>
+              <a:rPr lang="vi-VN" sz="4400" b="1" dirty="0">
+                <a:solidFill>
+                  <a:srgbClr val="660033"/>
+                </a:solidFill>
+                <a:latin typeface="Calibri" panose="020F0502020204030204" pitchFamily="34" charset="0"/>
+                <a:ea typeface="微軟正黑體" pitchFamily="34" charset="-120"/>
+                <a:cs typeface="Calibri" panose="020F0502020204030204" pitchFamily="34" charset="0"/>
+              </a:rPr>
+              <a:t>ào cùng nắm tay tươi cười</a:t>
+            </a:r>
+            <a:endParaRPr lang="en-US" sz="4400" b="1" dirty="0">
               <a:solidFill>
                 <a:srgbClr val="660033"/>
               </a:solidFill>
@@ -3833,7 +5150,13 @@
       </p:sp>
       <p:sp>
         <p:nvSpPr>
-          <p:cNvPr id="8" name="TextBox 7"/>
+          <p:cNvPr id="8" name="TextBox 7">
+            <a:extLst>
+              <a:ext uri="{FF2B5EF4-FFF2-40B4-BE49-F238E27FC236}">
+                <a16:creationId xmlns:a16="http://schemas.microsoft.com/office/drawing/2014/main" id="{F5BC3A4F-AC9A-1202-7B00-C8BE034466A2}"/>
+              </a:ext>
+            </a:extLst>
+          </p:cNvPr>
           <p:cNvSpPr txBox="1"/>
           <p:nvPr/>
         </p:nvSpPr>
@@ -3859,6 +5182,7 @@
                 <a:solidFill>
                   <a:srgbClr val="000066"/>
                 </a:solidFill>
+                <a:effectLst/>
                 <a:latin typeface="Microsoft JhengHei" panose="020B0604030504040204" pitchFamily="34" charset="-120"/>
                 <a:ea typeface="Microsoft JhengHei" panose="020B0604030504040204" pitchFamily="34" charset="-120"/>
               </a:rPr>
@@ -3869,6 +5193,7 @@
                 <a:solidFill>
                   <a:srgbClr val="000066"/>
                 </a:solidFill>
+                <a:effectLst/>
                 <a:latin typeface="Microsoft JhengHei" panose="020B0604030504040204" pitchFamily="34" charset="-120"/>
                 <a:ea typeface="Microsoft JhengHei" panose="020B0604030504040204" pitchFamily="34" charset="-120"/>
               </a:rPr>
@@ -3879,6 +5204,7 @@
                 <a:solidFill>
                   <a:srgbClr val="000066"/>
                 </a:solidFill>
+                <a:effectLst/>
                 <a:latin typeface="Microsoft JhengHei" panose="020B0604030504040204" pitchFamily="34" charset="-120"/>
                 <a:ea typeface="Microsoft JhengHei" panose="020B0604030504040204" pitchFamily="34" charset="-120"/>
               </a:rPr>
@@ -3888,6 +5214,7 @@
               <a:solidFill>
                 <a:srgbClr val="000066"/>
               </a:solidFill>
+              <a:effectLst/>
               <a:ea typeface="Microsoft JhengHei" panose="020B0604030504040204" pitchFamily="34" charset="-120"/>
             </a:endParaRPr>
           </a:p>
@@ -3896,7 +5223,7 @@
     </p:spTree>
     <p:extLst>
       <p:ext uri="{BB962C8B-B14F-4D97-AF65-F5344CB8AC3E}">
-        <p14:creationId xmlns:p14="http://schemas.microsoft.com/office/powerpoint/2010/main" val="3832456834"/>
+        <p14:creationId xmlns:p14="http://schemas.microsoft.com/office/powerpoint/2010/main" val="696776354"/>
       </p:ext>
     </p:extLst>
   </p:cSld>
@@ -3956,7 +5283,7 @@
                 <a:latin typeface="微軟正黑體" pitchFamily="34" charset="-120"/>
                 <a:ea typeface="微軟正黑體" pitchFamily="34" charset="-120"/>
               </a:rPr>
-              <a:t>神加添世人  平安加喜樂</a:t>
+              <a:t>耶穌甘替罪</a:t>
             </a:r>
             <a:endParaRPr lang="en-US" altLang="zh-CN" sz="6400" b="1" dirty="0">
               <a:solidFill>
@@ -4131,7 +5458,7 @@
               <a:buNone/>
             </a:pPr>
             <a:r>
-              <a:rPr lang="vi-VN" sz="3600" b="1" dirty="0">
+              <a:rPr lang="vi-VN" sz="4400" b="1" dirty="0">
                 <a:solidFill>
                   <a:srgbClr val="660033"/>
                 </a:solidFill>
@@ -4139,9 +5466,9 @@
                 <a:ea typeface="微軟正黑體" pitchFamily="34" charset="-120"/>
                 <a:cs typeface="Calibri" panose="020F0502020204030204" pitchFamily="34" charset="0"/>
               </a:rPr>
-              <a:t>Mừng ngày giáng sinh an hoà, mừng hạnh phúc cho muôn nhà</a:t>
-            </a:r>
-            <a:endParaRPr lang="en-US" sz="3600" b="1" dirty="0">
+              <a:t>Hoà bình đến cho muôn người</a:t>
+            </a:r>
+            <a:endParaRPr lang="en-US" sz="4400" b="1" dirty="0">
               <a:solidFill>
                 <a:srgbClr val="660033"/>
               </a:solidFill>
@@ -4217,7 +5544,7 @@
     </p:spTree>
     <p:extLst>
       <p:ext uri="{BB962C8B-B14F-4D97-AF65-F5344CB8AC3E}">
-        <p14:creationId xmlns:p14="http://schemas.microsoft.com/office/powerpoint/2010/main" val="2107940712"/>
+        <p14:creationId xmlns:p14="http://schemas.microsoft.com/office/powerpoint/2010/main" val="3832456834"/>
       </p:ext>
     </p:extLst>
   </p:cSld>
@@ -4232,7 +5559,13 @@
   <p:cSld>
     <p:spTree>
       <p:nvGrpSpPr>
-        <p:cNvPr id="1" name=""/>
+        <p:cNvPr id="1" name="">
+          <a:extLst>
+            <a:ext uri="{FF2B5EF4-FFF2-40B4-BE49-F238E27FC236}">
+              <a16:creationId xmlns:a16="http://schemas.microsoft.com/office/drawing/2014/main" id="{4C2B5CB9-5247-F827-0725-A17912297442}"/>
+            </a:ext>
+          </a:extLst>
+        </p:cNvPr>
         <p:cNvGrpSpPr/>
         <p:nvPr/>
       </p:nvGrpSpPr>
@@ -4246,7 +5579,13 @@
       </p:grpSpPr>
       <p:sp>
         <p:nvSpPr>
-          <p:cNvPr id="6" name="內容版面配置區 4"/>
+          <p:cNvPr id="6" name="內容版面配置區 4">
+            <a:extLst>
+              <a:ext uri="{FF2B5EF4-FFF2-40B4-BE49-F238E27FC236}">
+                <a16:creationId xmlns:a16="http://schemas.microsoft.com/office/drawing/2014/main" id="{F7BB36BA-7E74-B5A1-0279-162AEEBD8597}"/>
+              </a:ext>
+            </a:extLst>
+          </p:cNvPr>
           <p:cNvSpPr>
             <a:spLocks noGrp="1"/>
           </p:cNvSpPr>
@@ -4277,27 +5616,7 @@
                 <a:latin typeface="微軟正黑體" pitchFamily="34" charset="-120"/>
                 <a:ea typeface="微軟正黑體" pitchFamily="34" charset="-120"/>
               </a:rPr>
-              <a:t>離開黑暗無有怕</a:t>
-            </a:r>
-            <a:r>
-              <a:rPr lang="vi-VN" altLang="zh-TW" sz="6400" b="1" dirty="0">
-                <a:solidFill>
-                  <a:srgbClr val="000066"/>
-                </a:solidFill>
-                <a:latin typeface="微軟正黑體" pitchFamily="34" charset="-120"/>
-                <a:ea typeface="微軟正黑體" pitchFamily="34" charset="-120"/>
-              </a:rPr>
-              <a:t>  </a:t>
-            </a:r>
-            <a:r>
-              <a:rPr lang="zh-TW" altLang="en-US" sz="6400" b="1" dirty="0">
-                <a:solidFill>
-                  <a:srgbClr val="000066"/>
-                </a:solidFill>
-                <a:latin typeface="微軟正黑體" pitchFamily="34" charset="-120"/>
-                <a:ea typeface="微軟正黑體" pitchFamily="34" charset="-120"/>
-              </a:rPr>
-              <a:t>變輕鬆快樂人</a:t>
+              <a:t>改寫死與生</a:t>
             </a:r>
             <a:endParaRPr lang="en-US" altLang="zh-CN" sz="6400" b="1" dirty="0">
               <a:solidFill>
@@ -4311,7 +5630,13 @@
       </p:sp>
       <p:sp>
         <p:nvSpPr>
-          <p:cNvPr id="7" name="內容版面配置區 4"/>
+          <p:cNvPr id="7" name="內容版面配置區 4">
+            <a:extLst>
+              <a:ext uri="{FF2B5EF4-FFF2-40B4-BE49-F238E27FC236}">
+                <a16:creationId xmlns:a16="http://schemas.microsoft.com/office/drawing/2014/main" id="{EFF7CF90-6913-ECC2-16D6-FBB39D106B57}"/>
+              </a:ext>
+            </a:extLst>
+          </p:cNvPr>
           <p:cNvSpPr txBox="1">
             <a:spLocks/>
           </p:cNvSpPr>
@@ -4472,7 +5797,7 @@
               <a:buNone/>
             </a:pPr>
             <a:r>
-              <a:rPr lang="vi-VN" sz="3300" b="1" dirty="0">
+              <a:rPr lang="vi-VN" sz="4400" b="1" dirty="0">
                 <a:solidFill>
                   <a:srgbClr val="660033"/>
                 </a:solidFill>
@@ -4480,9 +5805,9 @@
                 <a:ea typeface="微軟正黑體" pitchFamily="34" charset="-120"/>
                 <a:cs typeface="Calibri" panose="020F0502020204030204" pitchFamily="34" charset="0"/>
               </a:rPr>
-              <a:t>Từ thành phố hay đồng quê, muôn nơi vang tiếng hát ca vang lừng</a:t>
-            </a:r>
-            <a:endParaRPr lang="en-US" sz="3300" b="1" dirty="0">
+              <a:t>cùng cất tiếng ca mừng vui</a:t>
+            </a:r>
+            <a:endParaRPr lang="en-US" sz="4400" b="1" dirty="0">
               <a:solidFill>
                 <a:srgbClr val="660033"/>
               </a:solidFill>
@@ -4495,7 +5820,13 @@
       </p:sp>
       <p:sp>
         <p:nvSpPr>
-          <p:cNvPr id="8" name="TextBox 7"/>
+          <p:cNvPr id="8" name="TextBox 7">
+            <a:extLst>
+              <a:ext uri="{FF2B5EF4-FFF2-40B4-BE49-F238E27FC236}">
+                <a16:creationId xmlns:a16="http://schemas.microsoft.com/office/drawing/2014/main" id="{BCAD1DDD-6838-AC7A-170B-F1307206A8A6}"/>
+              </a:ext>
+            </a:extLst>
+          </p:cNvPr>
           <p:cNvSpPr txBox="1"/>
           <p:nvPr/>
         </p:nvSpPr>
@@ -4558,7 +5889,7 @@
     </p:spTree>
     <p:extLst>
       <p:ext uri="{BB962C8B-B14F-4D97-AF65-F5344CB8AC3E}">
-        <p14:creationId xmlns:p14="http://schemas.microsoft.com/office/powerpoint/2010/main" val="3061212476"/>
+        <p14:creationId xmlns:p14="http://schemas.microsoft.com/office/powerpoint/2010/main" val="3963964265"/>
       </p:ext>
     </p:extLst>
   </p:cSld>
@@ -4618,7 +5949,7 @@
                 <a:latin typeface="微軟正黑體" pitchFamily="34" charset="-120"/>
                 <a:ea typeface="微軟正黑體" pitchFamily="34" charset="-120"/>
               </a:rPr>
-              <a:t>閃星星  閃星星  救主已降生</a:t>
+              <a:t>神加添世人</a:t>
             </a:r>
             <a:endParaRPr lang="en-US" altLang="zh-CN" sz="6400" b="1" dirty="0">
               <a:solidFill>
@@ -4793,7 +6124,7 @@
               <a:buNone/>
             </a:pPr>
             <a:r>
-              <a:rPr lang="vi-VN" sz="4000" b="1" dirty="0">
+              <a:rPr lang="vi-VN" sz="4400" b="1" dirty="0">
                 <a:solidFill>
                   <a:srgbClr val="660033"/>
                 </a:solidFill>
@@ -4801,9 +6132,9 @@
                 <a:ea typeface="微軟正黑體" pitchFamily="34" charset="-120"/>
                 <a:cs typeface="Calibri" panose="020F0502020204030204" pitchFamily="34" charset="0"/>
               </a:rPr>
-              <a:t>Đêm Noel, đêm Noel, ta hãy cùng vui lên</a:t>
-            </a:r>
-            <a:endParaRPr lang="en-US" sz="4000" b="1" dirty="0">
+              <a:t>Mừng ngày giáng sinh an hoà</a:t>
+            </a:r>
+            <a:endParaRPr lang="en-US" sz="4400" b="1" dirty="0">
               <a:solidFill>
                 <a:srgbClr val="660033"/>
               </a:solidFill>
@@ -4855,7 +6186,7 @@
                 <a:latin typeface="Microsoft JhengHei" panose="020B0604030504040204" pitchFamily="34" charset="-120"/>
                 <a:ea typeface="Microsoft JhengHei" panose="020B0604030504040204" pitchFamily="34" charset="-120"/>
               </a:rPr>
-              <a:t>副歌</a:t>
+              <a:t>正歌</a:t>
             </a:r>
             <a:r>
               <a:rPr lang="en-US" sz="3600" b="1" dirty="0">
@@ -4879,7 +6210,7 @@
     </p:spTree>
     <p:extLst>
       <p:ext uri="{BB962C8B-B14F-4D97-AF65-F5344CB8AC3E}">
-        <p14:creationId xmlns:p14="http://schemas.microsoft.com/office/powerpoint/2010/main" val="1232539337"/>
+        <p14:creationId xmlns:p14="http://schemas.microsoft.com/office/powerpoint/2010/main" val="2107940712"/>
       </p:ext>
     </p:extLst>
   </p:cSld>
@@ -4894,7 +6225,13 @@
   <p:cSld>
     <p:spTree>
       <p:nvGrpSpPr>
-        <p:cNvPr id="1" name=""/>
+        <p:cNvPr id="1" name="">
+          <a:extLst>
+            <a:ext uri="{FF2B5EF4-FFF2-40B4-BE49-F238E27FC236}">
+              <a16:creationId xmlns:a16="http://schemas.microsoft.com/office/drawing/2014/main" id="{B631C166-E62B-6964-6848-EDE2BA233E04}"/>
+            </a:ext>
+          </a:extLst>
+        </p:cNvPr>
         <p:cNvGrpSpPr/>
         <p:nvPr/>
       </p:nvGrpSpPr>
@@ -4908,7 +6245,13 @@
       </p:grpSpPr>
       <p:sp>
         <p:nvSpPr>
-          <p:cNvPr id="6" name="內容版面配置區 4"/>
+          <p:cNvPr id="6" name="內容版面配置區 4">
+            <a:extLst>
+              <a:ext uri="{FF2B5EF4-FFF2-40B4-BE49-F238E27FC236}">
+                <a16:creationId xmlns:a16="http://schemas.microsoft.com/office/drawing/2014/main" id="{C35D7A5D-EBE7-720D-A85A-C1B39F692E56}"/>
+              </a:ext>
+            </a:extLst>
+          </p:cNvPr>
           <p:cNvSpPr>
             <a:spLocks noGrp="1"/>
           </p:cNvSpPr>
@@ -4939,7 +6282,7 @@
                 <a:latin typeface="微軟正黑體" pitchFamily="34" charset="-120"/>
                 <a:ea typeface="微軟正黑體" pitchFamily="34" charset="-120"/>
               </a:rPr>
-              <a:t>聖誕節  多開心  萬民同頌神恩</a:t>
+              <a:t>平安加喜樂</a:t>
             </a:r>
             <a:endParaRPr lang="en-US" altLang="zh-CN" sz="6400" b="1" dirty="0">
               <a:solidFill>
@@ -4953,7 +6296,13 @@
       </p:sp>
       <p:sp>
         <p:nvSpPr>
-          <p:cNvPr id="7" name="內容版面配置區 4"/>
+          <p:cNvPr id="7" name="內容版面配置區 4">
+            <a:extLst>
+              <a:ext uri="{FF2B5EF4-FFF2-40B4-BE49-F238E27FC236}">
+                <a16:creationId xmlns:a16="http://schemas.microsoft.com/office/drawing/2014/main" id="{62D23C26-B5F9-2594-6F4B-2B8D47540494}"/>
+              </a:ext>
+            </a:extLst>
+          </p:cNvPr>
           <p:cNvSpPr txBox="1">
             <a:spLocks/>
           </p:cNvSpPr>
@@ -5114,7 +6463,7 @@
               <a:buNone/>
             </a:pPr>
             <a:r>
-              <a:rPr lang="vi-VN" sz="3600" b="1" dirty="0">
+              <a:rPr lang="en-US" sz="4400" b="1" dirty="0">
                 <a:solidFill>
                   <a:srgbClr val="660033"/>
                 </a:solidFill>
@@ -5122,9 +6471,20 @@
                 <a:ea typeface="微軟正黑體" pitchFamily="34" charset="-120"/>
                 <a:cs typeface="Calibri" panose="020F0502020204030204" pitchFamily="34" charset="0"/>
               </a:rPr>
-              <a:t>Đêm noel, đêm đêm ta xin ơn trên ban hoà bình cho trần thế</a:t>
-            </a:r>
-            <a:endParaRPr lang="en-US" sz="3600" b="1" dirty="0">
+              <a:t>M</a:t>
+            </a:r>
+            <a:r>
+              <a:rPr lang="vi-VN" sz="4400" b="1" dirty="0">
+                <a:solidFill>
+                  <a:srgbClr val="660033"/>
+                </a:solidFill>
+                <a:latin typeface="Calibri" panose="020F0502020204030204" pitchFamily="34" charset="0"/>
+                <a:ea typeface="微軟正黑體" pitchFamily="34" charset="-120"/>
+                <a:cs typeface="Calibri" panose="020F0502020204030204" pitchFamily="34" charset="0"/>
+              </a:rPr>
+              <a:t>ừng hạnh phúc cho muôn nhà</a:t>
+            </a:r>
+            <a:endParaRPr lang="en-US" sz="4400" b="1" dirty="0">
               <a:solidFill>
                 <a:srgbClr val="660033"/>
               </a:solidFill>
@@ -5137,7 +6497,13 @@
       </p:sp>
       <p:sp>
         <p:nvSpPr>
-          <p:cNvPr id="8" name="TextBox 7"/>
+          <p:cNvPr id="8" name="TextBox 7">
+            <a:extLst>
+              <a:ext uri="{FF2B5EF4-FFF2-40B4-BE49-F238E27FC236}">
+                <a16:creationId xmlns:a16="http://schemas.microsoft.com/office/drawing/2014/main" id="{1A3D8D58-CB9D-9945-196B-8E26E5EE0492}"/>
+              </a:ext>
+            </a:extLst>
+          </p:cNvPr>
           <p:cNvSpPr txBox="1"/>
           <p:nvPr/>
         </p:nvSpPr>
@@ -5176,7 +6542,7 @@
                 <a:latin typeface="Microsoft JhengHei" panose="020B0604030504040204" pitchFamily="34" charset="-120"/>
                 <a:ea typeface="Microsoft JhengHei" panose="020B0604030504040204" pitchFamily="34" charset="-120"/>
               </a:rPr>
-              <a:t>副歌</a:t>
+              <a:t>正歌</a:t>
             </a:r>
             <a:r>
               <a:rPr lang="en-US" sz="3600" b="1" dirty="0">
@@ -5200,7 +6566,7 @@
     </p:spTree>
     <p:extLst>
       <p:ext uri="{BB962C8B-B14F-4D97-AF65-F5344CB8AC3E}">
-        <p14:creationId xmlns:p14="http://schemas.microsoft.com/office/powerpoint/2010/main" val="3732715540"/>
+        <p14:creationId xmlns:p14="http://schemas.microsoft.com/office/powerpoint/2010/main" val="3609984194"/>
       </p:ext>
     </p:extLst>
   </p:cSld>
@@ -5260,7 +6626,7 @@
                 <a:latin typeface="微軟正黑體" pitchFamily="34" charset="-120"/>
                 <a:ea typeface="微軟正黑體" pitchFamily="34" charset="-120"/>
               </a:rPr>
-              <a:t>好開心  真開心  主恩滿我心</a:t>
+              <a:t>離開黑暗無有怕</a:t>
             </a:r>
             <a:endParaRPr lang="en-US" altLang="zh-CN" sz="6400" b="1" dirty="0">
               <a:solidFill>
@@ -5435,7 +6801,7 @@
               <a:buNone/>
             </a:pPr>
             <a:r>
-              <a:rPr lang="vi-VN" sz="4000" b="1" dirty="0">
+              <a:rPr lang="vi-VN" sz="4400" b="1" dirty="0">
                 <a:solidFill>
                   <a:srgbClr val="660033"/>
                 </a:solidFill>
@@ -5443,16 +6809,19 @@
                 <a:ea typeface="微軟正黑體" pitchFamily="34" charset="-120"/>
                 <a:cs typeface="Calibri" panose="020F0502020204030204" pitchFamily="34" charset="0"/>
               </a:rPr>
-              <a:t>Đêm Noel chuông vang lên chuông giáo đường vang lên</a:t>
-            </a:r>
-            <a:endParaRPr lang="en-US" sz="4000" b="1" dirty="0">
-              <a:solidFill>
-                <a:srgbClr val="660033"/>
-              </a:solidFill>
-              <a:latin typeface="Calibri" panose="020F0502020204030204" pitchFamily="34" charset="0"/>
-              <a:ea typeface="微軟正黑體" pitchFamily="34" charset="-120"/>
-              <a:cs typeface="Calibri" panose="020F0502020204030204" pitchFamily="34" charset="0"/>
-            </a:endParaRPr>
+              <a:t>Từ thành phố hay đồng quê, muôn nơi</a:t>
+            </a:r>
+            <a:r>
+              <a:rPr lang="en-US" sz="4400" b="1" dirty="0">
+                <a:solidFill>
+                  <a:srgbClr val="660033"/>
+                </a:solidFill>
+                <a:latin typeface="Calibri" panose="020F0502020204030204" pitchFamily="34" charset="0"/>
+                <a:ea typeface="微軟正黑體" pitchFamily="34" charset="-120"/>
+                <a:cs typeface="Calibri" panose="020F0502020204030204" pitchFamily="34" charset="0"/>
+              </a:rPr>
+              <a:t>…</a:t>
+            </a:r>
           </a:p>
         </p:txBody>
       </p:sp>
@@ -5497,7 +6866,7 @@
                 <a:latin typeface="Microsoft JhengHei" panose="020B0604030504040204" pitchFamily="34" charset="-120"/>
                 <a:ea typeface="Microsoft JhengHei" panose="020B0604030504040204" pitchFamily="34" charset="-120"/>
               </a:rPr>
-              <a:t>副歌</a:t>
+              <a:t>正歌</a:t>
             </a:r>
             <a:r>
               <a:rPr lang="en-US" sz="3600" b="1" dirty="0">
@@ -5521,7 +6890,7 @@
     </p:spTree>
     <p:extLst>
       <p:ext uri="{BB962C8B-B14F-4D97-AF65-F5344CB8AC3E}">
-        <p14:creationId xmlns:p14="http://schemas.microsoft.com/office/powerpoint/2010/main" val="1611647430"/>
+        <p14:creationId xmlns:p14="http://schemas.microsoft.com/office/powerpoint/2010/main" val="3061212476"/>
       </p:ext>
     </p:extLst>
   </p:cSld>
@@ -5536,7 +6905,13 @@
   <p:cSld>
     <p:spTree>
       <p:nvGrpSpPr>
-        <p:cNvPr id="1" name=""/>
+        <p:cNvPr id="1" name="">
+          <a:extLst>
+            <a:ext uri="{FF2B5EF4-FFF2-40B4-BE49-F238E27FC236}">
+              <a16:creationId xmlns:a16="http://schemas.microsoft.com/office/drawing/2014/main" id="{B27E81F3-6593-5B4E-5E52-8DF8F7B21D6D}"/>
+            </a:ext>
+          </a:extLst>
+        </p:cNvPr>
         <p:cNvGrpSpPr/>
         <p:nvPr/>
       </p:nvGrpSpPr>
@@ -5550,7 +6925,13 @@
       </p:grpSpPr>
       <p:sp>
         <p:nvSpPr>
-          <p:cNvPr id="6" name="內容版面配置區 4"/>
+          <p:cNvPr id="6" name="內容版面配置區 4">
+            <a:extLst>
+              <a:ext uri="{FF2B5EF4-FFF2-40B4-BE49-F238E27FC236}">
+                <a16:creationId xmlns:a16="http://schemas.microsoft.com/office/drawing/2014/main" id="{62808589-A333-7420-F9E6-8DFB3CFDFDB0}"/>
+              </a:ext>
+            </a:extLst>
+          </p:cNvPr>
           <p:cNvSpPr>
             <a:spLocks noGrp="1"/>
           </p:cNvSpPr>
@@ -5581,7 +6962,7 @@
                 <a:latin typeface="微軟正黑體" pitchFamily="34" charset="-120"/>
                 <a:ea typeface="微軟正黑體" pitchFamily="34" charset="-120"/>
               </a:rPr>
-              <a:t>你與我  快樂頌  願天天一起唱</a:t>
+              <a:t>變輕鬆快樂人</a:t>
             </a:r>
             <a:endParaRPr lang="en-US" altLang="zh-CN" sz="6400" b="1" dirty="0">
               <a:solidFill>
@@ -5595,7 +6976,13 @@
       </p:sp>
       <p:sp>
         <p:nvSpPr>
-          <p:cNvPr id="7" name="內容版面配置區 4"/>
+          <p:cNvPr id="7" name="內容版面配置區 4">
+            <a:extLst>
+              <a:ext uri="{FF2B5EF4-FFF2-40B4-BE49-F238E27FC236}">
+                <a16:creationId xmlns:a16="http://schemas.microsoft.com/office/drawing/2014/main" id="{310E75EA-0A9A-6DBA-FAF3-F05CEFF5C1AB}"/>
+              </a:ext>
+            </a:extLst>
+          </p:cNvPr>
           <p:cNvSpPr txBox="1">
             <a:spLocks/>
           </p:cNvSpPr>
@@ -5756,7 +7143,7 @@
               <a:buNone/>
             </a:pPr>
             <a:r>
-              <a:rPr lang="vi-VN" sz="4000" b="1" dirty="0">
+              <a:rPr lang="en-US" sz="4400" b="1" dirty="0">
                 <a:solidFill>
                   <a:srgbClr val="660033"/>
                 </a:solidFill>
@@ -5764,9 +7151,20 @@
                 <a:ea typeface="微軟正黑體" pitchFamily="34" charset="-120"/>
                 <a:cs typeface="Calibri" panose="020F0502020204030204" pitchFamily="34" charset="0"/>
               </a:rPr>
-              <a:t>Đêm Noel, đêm Noel, ta hãy chúc nhau an bình</a:t>
-            </a:r>
-            <a:endParaRPr lang="en-US" sz="4000" b="1" dirty="0">
+              <a:t>…</a:t>
+            </a:r>
+            <a:r>
+              <a:rPr lang="vi-VN" sz="4400" b="1" dirty="0">
+                <a:solidFill>
+                  <a:srgbClr val="660033"/>
+                </a:solidFill>
+                <a:latin typeface="Calibri" panose="020F0502020204030204" pitchFamily="34" charset="0"/>
+                <a:ea typeface="微軟正黑體" pitchFamily="34" charset="-120"/>
+                <a:cs typeface="Calibri" panose="020F0502020204030204" pitchFamily="34" charset="0"/>
+              </a:rPr>
+              <a:t>vang tiếng hát ca vang lừng</a:t>
+            </a:r>
+            <a:endParaRPr lang="en-US" sz="4400" b="1" dirty="0">
               <a:solidFill>
                 <a:srgbClr val="660033"/>
               </a:solidFill>
@@ -5779,7 +7177,13 @@
       </p:sp>
       <p:sp>
         <p:nvSpPr>
-          <p:cNvPr id="8" name="TextBox 7"/>
+          <p:cNvPr id="8" name="TextBox 7">
+            <a:extLst>
+              <a:ext uri="{FF2B5EF4-FFF2-40B4-BE49-F238E27FC236}">
+                <a16:creationId xmlns:a16="http://schemas.microsoft.com/office/drawing/2014/main" id="{465606DD-C9DC-CF08-BEAE-DD7EF92904E1}"/>
+              </a:ext>
+            </a:extLst>
+          </p:cNvPr>
           <p:cNvSpPr txBox="1"/>
           <p:nvPr/>
         </p:nvSpPr>
@@ -5818,7 +7222,7 @@
                 <a:latin typeface="Microsoft JhengHei" panose="020B0604030504040204" pitchFamily="34" charset="-120"/>
                 <a:ea typeface="Microsoft JhengHei" panose="020B0604030504040204" pitchFamily="34" charset="-120"/>
               </a:rPr>
-              <a:t>副歌</a:t>
+              <a:t>正歌</a:t>
             </a:r>
             <a:r>
               <a:rPr lang="en-US" sz="3600" b="1" dirty="0">
@@ -5842,7 +7246,7 @@
     </p:spTree>
     <p:extLst>
       <p:ext uri="{BB962C8B-B14F-4D97-AF65-F5344CB8AC3E}">
-        <p14:creationId xmlns:p14="http://schemas.microsoft.com/office/powerpoint/2010/main" val="599047401"/>
+        <p14:creationId xmlns:p14="http://schemas.microsoft.com/office/powerpoint/2010/main" val="1953250120"/>
       </p:ext>
     </p:extLst>
   </p:cSld>

</xml_diff>